<commit_message>
Add 4 backup slides to defense deck
Expands the single backup placeholder into a backup index plus four
content slides: full 9-config XGBoost/RF cache tables, the 15-model eta
viability ranking, the best-XGBoost confusion matrix, and the global vs.
per-fold feature-selection comparison. Adds rasterized assets and the
new-slide/table helpers to build_presentation.py.

https://claude.ai/code/session_01P9syRDuxUEthFVf8zcHciC
</commit_message>
<xml_diff>
--- a/thesis/presentation/Thesis_Presentation_Gorzel.pptx
+++ b/thesis/presentation/Thesis_Presentation_Gorzel.pptx
@@ -22,6 +22,10 @@
     <p:sldId id="4442" r:id="rId13"/>
     <p:sldId id="4446" r:id="rId14"/>
     <p:sldId id="4443" r:id="rId15"/>
+    <p:sldId id="4449" r:id="rId22"/>
+    <p:sldId id="4450" r:id="rId23"/>
+    <p:sldId id="4451" r:id="rId24"/>
+    <p:sldId id="4452" r:id="rId25"/>
   </p:sldIdLst>
   <p:sldSz cx="12192000" cy="6858000"/>
   <p:notesSz cx="6858000" cy="9144000"/>
@@ -955,7 +959,287 @@
           <a:lstStyle/>
           <a:p>
             <a:r>
-              <a:t>Optional. Pull these up only if asked. The global-vs-fold slide directly addresses the train-set leakage point.</a:t>
+              <a:t>Optional index. Pull the relevant slide up only if asked.</a:t>
+            </a:r>
+          </a:p>
+        </p:txBody>
+      </p:sp>
+      <p:sp>
+        <p:nvSpPr>
+          <p:cNvPr id="4" name="Slide Number Placeholder 3"/>
+          <p:cNvSpPr>
+            <a:spLocks noGrp="1"/>
+          </p:cNvSpPr>
+          <p:nvPr>
+            <p:ph type="sldNum" idx="5" sz="quarter"/>
+          </p:nvPr>
+        </p:nvSpPr>
+        <p:spPr/>
+      </p:sp>
+    </p:spTree>
+  </p:cSld>
+  <p:clrMapOvr>
+    <a:masterClrMapping/>
+  </p:clrMapOvr>
+</p:notes>
+</file>
+
+<file path=ppt/notesSlides/notesSlide12.xml><?xml version="1.0" encoding="utf-8"?>
+<p:notes xmlns:a="http://schemas.openxmlformats.org/drawingml/2006/main" xmlns:p="http://schemas.openxmlformats.org/presentationml/2006/main" xmlns:r="http://schemas.openxmlformats.org/officeDocument/2006/relationships">
+  <p:cSld>
+    <p:spTree>
+      <p:nvGrpSpPr>
+        <p:cNvPr id="1" name=""/>
+        <p:cNvGrpSpPr/>
+        <p:nvPr/>
+      </p:nvGrpSpPr>
+      <p:grpSpPr>
+        <a:xfrm>
+          <a:off x="0" y="0"/>
+          <a:ext cx="0" cy="0"/>
+          <a:chOff x="0" y="0"/>
+          <a:chExt cx="0" cy="0"/>
+        </a:xfrm>
+      </p:grpSpPr>
+      <p:sp>
+        <p:nvSpPr>
+          <p:cNvPr id="2" name="Slide Image Placeholder 1"/>
+          <p:cNvSpPr>
+            <a:spLocks noGrp="1"/>
+          </p:cNvSpPr>
+          <p:nvPr>
+            <p:ph type="sldImg" idx="2"/>
+          </p:nvPr>
+        </p:nvSpPr>
+        <p:spPr/>
+      </p:sp>
+      <p:sp>
+        <p:nvSpPr>
+          <p:cNvPr id="3" name="Notes Placeholder 2"/>
+          <p:cNvSpPr>
+            <a:spLocks noGrp="1"/>
+          </p:cNvSpPr>
+          <p:nvPr>
+            <p:ph type="body" idx="3" sz="quarter"/>
+          </p:nvPr>
+        </p:nvSpPr>
+        <p:spPr/>
+        <p:txBody>
+          <a:bodyPr/>
+          <a:lstStyle/>
+          <a:p>
+            <a:r>
+              <a:t>Per-configuration cache results, 128-fold LOSO. XGBoost: median 54×, ~185 MB, best config corr=None/k=None at 202×. Random Forest: median 11.6×, ~18.5 GB — meaningful speedup but GB-scale storage. All 2,304 warm operations were cache hits.</a:t>
+            </a:r>
+          </a:p>
+        </p:txBody>
+      </p:sp>
+      <p:sp>
+        <p:nvSpPr>
+          <p:cNvPr id="4" name="Slide Number Placeholder 3"/>
+          <p:cNvSpPr>
+            <a:spLocks noGrp="1"/>
+          </p:cNvSpPr>
+          <p:nvPr>
+            <p:ph type="sldNum" idx="5" sz="quarter"/>
+          </p:nvPr>
+        </p:nvSpPr>
+        <p:spPr/>
+      </p:sp>
+    </p:spTree>
+  </p:cSld>
+  <p:clrMapOvr>
+    <a:masterClrMapping/>
+  </p:clrMapOvr>
+</p:notes>
+</file>
+
+<file path=ppt/notesSlides/notesSlide13.xml><?xml version="1.0" encoding="utf-8"?>
+<p:notes xmlns:a="http://schemas.openxmlformats.org/drawingml/2006/main" xmlns:p="http://schemas.openxmlformats.org/presentationml/2006/main" xmlns:r="http://schemas.openxmlformats.org/officeDocument/2006/relationships">
+  <p:cSld>
+    <p:spTree>
+      <p:nvGrpSpPr>
+        <p:cNvPr id="1" name=""/>
+        <p:cNvGrpSpPr/>
+        <p:nvPr/>
+      </p:nvGrpSpPr>
+      <p:grpSpPr>
+        <a:xfrm>
+          <a:off x="0" y="0"/>
+          <a:ext cx="0" cy="0"/>
+          <a:chOff x="0" y="0"/>
+          <a:chExt cx="0" cy="0"/>
+        </a:xfrm>
+      </p:grpSpPr>
+      <p:sp>
+        <p:nvSpPr>
+          <p:cNvPr id="2" name="Slide Image Placeholder 1"/>
+          <p:cNvSpPr>
+            <a:spLocks noGrp="1"/>
+          </p:cNvSpPr>
+          <p:nvPr>
+            <p:ph type="sldImg" idx="2"/>
+          </p:nvPr>
+        </p:nvSpPr>
+        <p:spPr/>
+      </p:sp>
+      <p:sp>
+        <p:nvSpPr>
+          <p:cNvPr id="3" name="Notes Placeholder 2"/>
+          <p:cNvSpPr>
+            <a:spLocks noGrp="1"/>
+          </p:cNvSpPr>
+          <p:nvPr>
+            <p:ph type="body" idx="3" sz="quarter"/>
+          </p:nvPr>
+        </p:nvSpPr>
+        <p:spPr/>
+        <p:txBody>
+          <a:bodyPr/>
+          <a:lstStyle/>
+          <a:p>
+            <a:r>
+              <a:t>η ranking of all 15 model types. Eleven viable, four not (Random Forest, Extra Trees, kNN k=5/k=10). Caveat if asked: the tiny-cache models (gradient boosting, AdaBoost, SVM-linear) show very large η because their cache size rounds toward zero — read this alongside the two-axis scatter on the main Results slide, which also shows absolute time saved.</a:t>
+            </a:r>
+          </a:p>
+        </p:txBody>
+      </p:sp>
+      <p:sp>
+        <p:nvSpPr>
+          <p:cNvPr id="4" name="Slide Number Placeholder 3"/>
+          <p:cNvSpPr>
+            <a:spLocks noGrp="1"/>
+          </p:cNvSpPr>
+          <p:nvPr>
+            <p:ph type="sldNum" idx="5" sz="quarter"/>
+          </p:nvPr>
+        </p:nvSpPr>
+        <p:spPr/>
+      </p:sp>
+    </p:spTree>
+  </p:cSld>
+  <p:clrMapOvr>
+    <a:masterClrMapping/>
+  </p:clrMapOvr>
+</p:notes>
+</file>
+
+<file path=ppt/notesSlides/notesSlide14.xml><?xml version="1.0" encoding="utf-8"?>
+<p:notes xmlns:a="http://schemas.openxmlformats.org/drawingml/2006/main" xmlns:p="http://schemas.openxmlformats.org/presentationml/2006/main" xmlns:r="http://schemas.openxmlformats.org/officeDocument/2006/relationships">
+  <p:cSld>
+    <p:spTree>
+      <p:nvGrpSpPr>
+        <p:cNvPr id="1" name=""/>
+        <p:cNvGrpSpPr/>
+        <p:nvPr/>
+      </p:nvGrpSpPr>
+      <p:grpSpPr>
+        <a:xfrm>
+          <a:off x="0" y="0"/>
+          <a:ext cx="0" cy="0"/>
+          <a:chOff x="0" y="0"/>
+          <a:chExt cx="0" cy="0"/>
+        </a:xfrm>
+      </p:grpSpPr>
+      <p:sp>
+        <p:nvSpPr>
+          <p:cNvPr id="2" name="Slide Image Placeholder 1"/>
+          <p:cNvSpPr>
+            <a:spLocks noGrp="1"/>
+          </p:cNvSpPr>
+          <p:nvPr>
+            <p:ph type="sldImg" idx="2"/>
+          </p:nvPr>
+        </p:nvSpPr>
+        <p:spPr/>
+      </p:sp>
+      <p:sp>
+        <p:nvSpPr>
+          <p:cNvPr id="3" name="Notes Placeholder 2"/>
+          <p:cNvSpPr>
+            <a:spLocks noGrp="1"/>
+          </p:cNvSpPr>
+          <p:nvPr>
+            <p:ph type="body" idx="3" sz="quarter"/>
+          </p:nvPr>
+        </p:nvSpPr>
+        <p:spPr/>
+        <p:txBody>
+          <a:bodyPr/>
+          <a:lstStyle/>
+          <a:p>
+            <a:r>
+              <a:t>Aggregated confusion matrix, best XGBoost configuration, all 128 folds. N1 has the lowest recall — it is a transitional stage, only 3.7% of all epochs, and is most often confused with Wake and N2. This is the standard hard class in AASM sleep staging, not a caching artefact.</a:t>
+            </a:r>
+          </a:p>
+        </p:txBody>
+      </p:sp>
+      <p:sp>
+        <p:nvSpPr>
+          <p:cNvPr id="4" name="Slide Number Placeholder 3"/>
+          <p:cNvSpPr>
+            <a:spLocks noGrp="1"/>
+          </p:cNvSpPr>
+          <p:nvPr>
+            <p:ph type="sldNum" idx="5" sz="quarter"/>
+          </p:nvPr>
+        </p:nvSpPr>
+        <p:spPr/>
+      </p:sp>
+    </p:spTree>
+  </p:cSld>
+  <p:clrMapOvr>
+    <a:masterClrMapping/>
+  </p:clrMapOvr>
+</p:notes>
+</file>
+
+<file path=ppt/notesSlides/notesSlide15.xml><?xml version="1.0" encoding="utf-8"?>
+<p:notes xmlns:a="http://schemas.openxmlformats.org/drawingml/2006/main" xmlns:p="http://schemas.openxmlformats.org/presentationml/2006/main" xmlns:r="http://schemas.openxmlformats.org/officeDocument/2006/relationships">
+  <p:cSld>
+    <p:spTree>
+      <p:nvGrpSpPr>
+        <p:cNvPr id="1" name=""/>
+        <p:cNvGrpSpPr/>
+        <p:nvPr/>
+      </p:nvGrpSpPr>
+      <p:grpSpPr>
+        <a:xfrm>
+          <a:off x="0" y="0"/>
+          <a:ext cx="0" cy="0"/>
+          <a:chOff x="0" y="0"/>
+          <a:chExt cx="0" cy="0"/>
+        </a:xfrm>
+      </p:grpSpPr>
+      <p:sp>
+        <p:nvSpPr>
+          <p:cNvPr id="2" name="Slide Image Placeholder 1"/>
+          <p:cNvSpPr>
+            <a:spLocks noGrp="1"/>
+          </p:cNvSpPr>
+          <p:nvPr>
+            <p:ph type="sldImg" idx="2"/>
+          </p:nvPr>
+        </p:nvSpPr>
+        <p:spPr/>
+      </p:sp>
+      <p:sp>
+        <p:nvSpPr>
+          <p:cNvPr id="3" name="Notes Placeholder 2"/>
+          <p:cNvSpPr>
+            <a:spLocks noGrp="1"/>
+          </p:cNvSpPr>
+          <p:nvPr>
+            <p:ph type="body" idx="3" sz="quarter"/>
+          </p:nvPr>
+        </p:nvSpPr>
+        <p:spPr/>
+        <p:txBody>
+          <a:bodyPr/>
+          <a:lstStyle/>
+          <a:p>
+            <a:r>
+              <a:t>Global vs per-fold feature selection. Per-fold is statistically stricter — it removes the 0.8% label leakage — but it re-runs ANOVA on every warm load, collapsing XGBoost speedup from 14–23× to 4–9×. Global was chosen with the supervisor's approval; the empirical accuracy impact is ≤1.1% with no consistent direction. This slide directly addresses the train-set leakage point in the assessment.</a:t>
             </a:r>
           </a:p>
         </p:txBody>
@@ -16947,10 +17231,8 @@
           <a:lstStyle/>
           <a:p>
             <a:r>
-              <a:rPr lang="de-DE" dirty="0"/>
-              <a:t>Backup Slide</a:t>
-            </a:r>
-            <a:endParaRPr lang="en-US" dirty="0"/>
+              <a:t>Backup — Material</a:t>
+            </a:r>
           </a:p>
         </p:txBody>
       </p:sp>
@@ -16991,7 +17273,7 @@
                   <a:srgbClr val="FF9E1B"/>
                 </a:solidFill>
               </a:rPr>
-              <a:t>Backup material</a:t>
+              <a:t>The following slides support likely questions</a:t>
             </a:r>
           </a:p>
           <a:p>
@@ -17002,7 +17284,7 @@
             </a:pPr>
             <a:r>
               <a:rPr sz="1800" b="0"/>
-              <a:t>Full 9-config results table (XGB + RF)</a:t>
+              <a:t>B1 — Full 9-config cache results (XGB + RF)</a:t>
             </a:r>
           </a:p>
           <a:p>
@@ -17013,7 +17295,7 @@
             </a:pPr>
             <a:r>
               <a:rPr sz="1800" b="0"/>
-              <a:t>η ranking — all 15 models</a:t>
+              <a:t>B2 — η ranking, all 15 models</a:t>
             </a:r>
           </a:p>
           <a:p>
@@ -17024,7 +17306,7 @@
             </a:pPr>
             <a:r>
               <a:rPr sz="1800" b="0"/>
-              <a:t>Confusion matrix + per-class F1 (N1)</a:t>
+              <a:t>B3 — Confusion matrix (N1 weakness)</a:t>
             </a:r>
           </a:p>
           <a:p>
@@ -17035,7 +17317,7 @@
             </a:pPr>
             <a:r>
               <a:rPr sz="1800" b="0"/>
-              <a:t>Global vs. per-fold selection (≤1.1%)</a:t>
+              <a:t>B4 — Global vs. per-fold selection (leakage)</a:t>
             </a:r>
           </a:p>
         </p:txBody>
@@ -17133,6 +17415,3247 @@
         <p14:creationId xmlns:p14="http://schemas.microsoft.com/office/powerpoint/2010/main" val="2719296134"/>
       </p:ext>
     </p:extLst>
+  </p:cSld>
+  <p:clrMapOvr>
+    <a:masterClrMapping/>
+  </p:clrMapOvr>
+</p:sld>
+</file>
+
+<file path=ppt/slides/slide12.xml><?xml version="1.0" encoding="utf-8"?>
+<p:sld xmlns:a="http://schemas.openxmlformats.org/drawingml/2006/main" xmlns:p="http://schemas.openxmlformats.org/presentationml/2006/main" xmlns:r="http://schemas.openxmlformats.org/officeDocument/2006/relationships">
+  <p:cSld>
+    <p:spTree>
+      <p:nvGrpSpPr>
+        <p:cNvPr id="1" name=""/>
+        <p:cNvGrpSpPr/>
+        <p:nvPr/>
+      </p:nvGrpSpPr>
+      <p:grpSpPr/>
+      <p:sp>
+        <p:nvSpPr>
+          <p:cNvPr id="2" name="Title 1"/>
+          <p:cNvSpPr>
+            <a:spLocks noGrp="1"/>
+          </p:cNvSpPr>
+          <p:nvPr>
+            <p:ph type="title"/>
+          </p:nvPr>
+        </p:nvSpPr>
+        <p:spPr/>
+        <p:txBody>
+          <a:bodyPr/>
+          <a:lstStyle/>
+          <a:p>
+            <a:r>
+              <a:t>Backup — Full Cache Results (128-fold LOSO)</a:t>
+            </a:r>
+          </a:p>
+        </p:txBody>
+      </p:sp>
+      <p:sp>
+        <p:nvSpPr>
+          <p:cNvPr id="3" name="TextBox 2"/>
+          <p:cNvSpPr txBox="1"/>
+          <p:nvPr/>
+        </p:nvSpPr>
+        <p:spPr>
+          <a:xfrm>
+            <a:off x="822960" y="1371600"/>
+            <a:ext cx="10515600" cy="274320"/>
+          </a:xfrm>
+          <a:prstGeom prst="rect">
+            <a:avLst/>
+          </a:prstGeom>
+          <a:noFill/>
+        </p:spPr>
+        <p:txBody>
+          <a:bodyPr wrap="none">
+            <a:spAutoFit/>
+          </a:bodyPr>
+          <a:lstStyle/>
+          <a:p>
+            <a:r>
+              <a:rPr sz="1400" b="1">
+                <a:solidFill>
+                  <a:srgbClr val="FF9E1B"/>
+                </a:solidFill>
+              </a:rPr>
+              <a:t>XGBoost — median 54×, ~185 MB  (best: 202×, 3816 s → 18.9 s)</a:t>
+            </a:r>
+          </a:p>
+        </p:txBody>
+      </p:sp>
+      <p:graphicFrame>
+        <p:nvGraphicFramePr>
+          <p:cNvPr id="4" name="Table 3"/>
+          <p:cNvGraphicFramePr>
+            <a:graphicFrameLocks noGrp="1"/>
+          </p:cNvGraphicFramePr>
+          <p:nvPr/>
+        </p:nvGraphicFramePr>
+        <p:xfrm>
+          <a:off x="822960" y="1664208"/>
+          <a:ext cx="10515600" cy="2057400"/>
+        </p:xfrm>
+        <a:graphic>
+          <a:graphicData uri="http://schemas.openxmlformats.org/drawingml/2006/table">
+            <a:tbl>
+              <a:tblPr firstRow="1" bandRow="1">
+                <a:tableStyleId>{5C22544A-7EE6-4342-B048-85BDC9FD1C3A}</a:tableStyleId>
+              </a:tblPr>
+              <a:tblGrid>
+                <a:gridCol w="3383280"/>
+                <a:gridCol w="1783080"/>
+                <a:gridCol w="1783080"/>
+                <a:gridCol w="1783080"/>
+                <a:gridCol w="1783080"/>
+              </a:tblGrid>
+              <a:tr h="205740">
+                <a:tc>
+                  <a:txBody>
+                    <a:bodyPr wrap="square"/>
+                    <a:lstStyle/>
+                    <a:p>
+                      <a:r>
+                        <a:rPr sz="1000" b="1">
+                          <a:solidFill>
+                            <a:srgbClr val="FFFFFF"/>
+                          </a:solidFill>
+                          <a:latin typeface="Arial"/>
+                        </a:rPr>
+                        <a:t>Config</a:t>
+                      </a:r>
+                    </a:p>
+                  </a:txBody>
+                  <a:tcPr anchor="ctr" marT="12700" marB="12700" marL="63500" marR="63500">
+                    <a:solidFill>
+                      <a:srgbClr val="FF9E1B"/>
+                    </a:solidFill>
+                  </a:tcPr>
+                </a:tc>
+                <a:tc>
+                  <a:txBody>
+                    <a:bodyPr wrap="square"/>
+                    <a:lstStyle/>
+                    <a:p>
+                      <a:r>
+                        <a:rPr sz="1000" b="1">
+                          <a:solidFill>
+                            <a:srgbClr val="FFFFFF"/>
+                          </a:solidFill>
+                          <a:latin typeface="Arial"/>
+                        </a:rPr>
+                        <a:t>Cold (s)</a:t>
+                      </a:r>
+                    </a:p>
+                  </a:txBody>
+                  <a:tcPr anchor="ctr" marT="12700" marB="12700" marL="63500" marR="63500">
+                    <a:solidFill>
+                      <a:srgbClr val="FF9E1B"/>
+                    </a:solidFill>
+                  </a:tcPr>
+                </a:tc>
+                <a:tc>
+                  <a:txBody>
+                    <a:bodyPr wrap="square"/>
+                    <a:lstStyle/>
+                    <a:p>
+                      <a:r>
+                        <a:rPr sz="1000" b="1">
+                          <a:solidFill>
+                            <a:srgbClr val="FFFFFF"/>
+                          </a:solidFill>
+                          <a:latin typeface="Arial"/>
+                        </a:rPr>
+                        <a:t>Warm (s)</a:t>
+                      </a:r>
+                    </a:p>
+                  </a:txBody>
+                  <a:tcPr anchor="ctr" marT="12700" marB="12700" marL="63500" marR="63500">
+                    <a:solidFill>
+                      <a:srgbClr val="FF9E1B"/>
+                    </a:solidFill>
+                  </a:tcPr>
+                </a:tc>
+                <a:tc>
+                  <a:txBody>
+                    <a:bodyPr wrap="square"/>
+                    <a:lstStyle/>
+                    <a:p>
+                      <a:r>
+                        <a:rPr sz="1000" b="1">
+                          <a:solidFill>
+                            <a:srgbClr val="FFFFFF"/>
+                          </a:solidFill>
+                          <a:latin typeface="Arial"/>
+                        </a:rPr>
+                        <a:t>Speedup</a:t>
+                      </a:r>
+                    </a:p>
+                  </a:txBody>
+                  <a:tcPr anchor="ctr" marT="12700" marB="12700" marL="63500" marR="63500">
+                    <a:solidFill>
+                      <a:srgbClr val="FF9E1B"/>
+                    </a:solidFill>
+                  </a:tcPr>
+                </a:tc>
+                <a:tc>
+                  <a:txBody>
+                    <a:bodyPr wrap="square"/>
+                    <a:lstStyle/>
+                    <a:p>
+                      <a:r>
+                        <a:rPr sz="1000" b="1">
+                          <a:solidFill>
+                            <a:srgbClr val="FFFFFF"/>
+                          </a:solidFill>
+                          <a:latin typeface="Arial"/>
+                        </a:rPr>
+                        <a:t>Cache</a:t>
+                      </a:r>
+                    </a:p>
+                  </a:txBody>
+                  <a:tcPr anchor="ctr" marT="12700" marB="12700" marL="63500" marR="63500">
+                    <a:solidFill>
+                      <a:srgbClr val="FF9E1B"/>
+                    </a:solidFill>
+                  </a:tcPr>
+                </a:tc>
+              </a:tr>
+              <a:tr h="205740">
+                <a:tc>
+                  <a:txBody>
+                    <a:bodyPr wrap="square"/>
+                    <a:lstStyle/>
+                    <a:p>
+                      <a:r>
+                        <a:rPr sz="1000">
+                          <a:solidFill>
+                            <a:srgbClr val="262B2F"/>
+                          </a:solidFill>
+                          <a:latin typeface="Arial"/>
+                        </a:rPr>
+                        <a:t>corr=0.75, k=30</a:t>
+                      </a:r>
+                    </a:p>
+                  </a:txBody>
+                  <a:tcPr anchor="ctr" marT="12700" marB="12700" marL="63500" marR="63500">
+                    <a:solidFill>
+                      <a:srgbClr val="FFFFFF"/>
+                    </a:solidFill>
+                  </a:tcPr>
+                </a:tc>
+                <a:tc>
+                  <a:txBody>
+                    <a:bodyPr wrap="square"/>
+                    <a:lstStyle/>
+                    <a:p>
+                      <a:r>
+                        <a:rPr sz="1000">
+                          <a:solidFill>
+                            <a:srgbClr val="262B2F"/>
+                          </a:solidFill>
+                          <a:latin typeface="Arial"/>
+                        </a:rPr>
+                        <a:t>1053.4</a:t>
+                      </a:r>
+                    </a:p>
+                  </a:txBody>
+                  <a:tcPr anchor="ctr" marT="12700" marB="12700" marL="63500" marR="63500">
+                    <a:solidFill>
+                      <a:srgbClr val="FFFFFF"/>
+                    </a:solidFill>
+                  </a:tcPr>
+                </a:tc>
+                <a:tc>
+                  <a:txBody>
+                    <a:bodyPr wrap="square"/>
+                    <a:lstStyle/>
+                    <a:p>
+                      <a:r>
+                        <a:rPr sz="1000">
+                          <a:solidFill>
+                            <a:srgbClr val="262B2F"/>
+                          </a:solidFill>
+                          <a:latin typeface="Arial"/>
+                        </a:rPr>
+                        <a:t>26.4</a:t>
+                      </a:r>
+                    </a:p>
+                  </a:txBody>
+                  <a:tcPr anchor="ctr" marT="12700" marB="12700" marL="63500" marR="63500">
+                    <a:solidFill>
+                      <a:srgbClr val="FFFFFF"/>
+                    </a:solidFill>
+                  </a:tcPr>
+                </a:tc>
+                <a:tc>
+                  <a:txBody>
+                    <a:bodyPr wrap="square"/>
+                    <a:lstStyle/>
+                    <a:p>
+                      <a:r>
+                        <a:rPr sz="1000">
+                          <a:solidFill>
+                            <a:srgbClr val="262B2F"/>
+                          </a:solidFill>
+                          <a:latin typeface="Arial"/>
+                        </a:rPr>
+                        <a:t>39.9×</a:t>
+                      </a:r>
+                    </a:p>
+                  </a:txBody>
+                  <a:tcPr anchor="ctr" marT="12700" marB="12700" marL="63500" marR="63500">
+                    <a:solidFill>
+                      <a:srgbClr val="FFFFFF"/>
+                    </a:solidFill>
+                  </a:tcPr>
+                </a:tc>
+                <a:tc>
+                  <a:txBody>
+                    <a:bodyPr wrap="square"/>
+                    <a:lstStyle/>
+                    <a:p>
+                      <a:r>
+                        <a:rPr sz="1000">
+                          <a:solidFill>
+                            <a:srgbClr val="262B2F"/>
+                          </a:solidFill>
+                          <a:latin typeface="Arial"/>
+                        </a:rPr>
+                        <a:t>186 MB</a:t>
+                      </a:r>
+                    </a:p>
+                  </a:txBody>
+                  <a:tcPr anchor="ctr" marT="12700" marB="12700" marL="63500" marR="63500">
+                    <a:solidFill>
+                      <a:srgbClr val="FFFFFF"/>
+                    </a:solidFill>
+                  </a:tcPr>
+                </a:tc>
+              </a:tr>
+              <a:tr h="205740">
+                <a:tc>
+                  <a:txBody>
+                    <a:bodyPr wrap="square"/>
+                    <a:lstStyle/>
+                    <a:p>
+                      <a:r>
+                        <a:rPr sz="1000">
+                          <a:solidFill>
+                            <a:srgbClr val="262B2F"/>
+                          </a:solidFill>
+                          <a:latin typeface="Arial"/>
+                        </a:rPr>
+                        <a:t>corr=0.75, k=50</a:t>
+                      </a:r>
+                    </a:p>
+                  </a:txBody>
+                  <a:tcPr anchor="ctr" marT="12700" marB="12700" marL="63500" marR="63500">
+                    <a:solidFill>
+                      <a:srgbClr val="FFFFFF"/>
+                    </a:solidFill>
+                  </a:tcPr>
+                </a:tc>
+                <a:tc>
+                  <a:txBody>
+                    <a:bodyPr wrap="square"/>
+                    <a:lstStyle/>
+                    <a:p>
+                      <a:r>
+                        <a:rPr sz="1000">
+                          <a:solidFill>
+                            <a:srgbClr val="262B2F"/>
+                          </a:solidFill>
+                          <a:latin typeface="Arial"/>
+                        </a:rPr>
+                        <a:t>1447.4</a:t>
+                      </a:r>
+                    </a:p>
+                  </a:txBody>
+                  <a:tcPr anchor="ctr" marT="12700" marB="12700" marL="63500" marR="63500">
+                    <a:solidFill>
+                      <a:srgbClr val="FFFFFF"/>
+                    </a:solidFill>
+                  </a:tcPr>
+                </a:tc>
+                <a:tc>
+                  <a:txBody>
+                    <a:bodyPr wrap="square"/>
+                    <a:lstStyle/>
+                    <a:p>
+                      <a:r>
+                        <a:rPr sz="1000">
+                          <a:solidFill>
+                            <a:srgbClr val="262B2F"/>
+                          </a:solidFill>
+                          <a:latin typeface="Arial"/>
+                        </a:rPr>
+                        <a:t>27.2</a:t>
+                      </a:r>
+                    </a:p>
+                  </a:txBody>
+                  <a:tcPr anchor="ctr" marT="12700" marB="12700" marL="63500" marR="63500">
+                    <a:solidFill>
+                      <a:srgbClr val="FFFFFF"/>
+                    </a:solidFill>
+                  </a:tcPr>
+                </a:tc>
+                <a:tc>
+                  <a:txBody>
+                    <a:bodyPr wrap="square"/>
+                    <a:lstStyle/>
+                    <a:p>
+                      <a:r>
+                        <a:rPr sz="1000">
+                          <a:solidFill>
+                            <a:srgbClr val="262B2F"/>
+                          </a:solidFill>
+                          <a:latin typeface="Arial"/>
+                        </a:rPr>
+                        <a:t>53.3×</a:t>
+                      </a:r>
+                    </a:p>
+                  </a:txBody>
+                  <a:tcPr anchor="ctr" marT="12700" marB="12700" marL="63500" marR="63500">
+                    <a:solidFill>
+                      <a:srgbClr val="FFFFFF"/>
+                    </a:solidFill>
+                  </a:tcPr>
+                </a:tc>
+                <a:tc>
+                  <a:txBody>
+                    <a:bodyPr wrap="square"/>
+                    <a:lstStyle/>
+                    <a:p>
+                      <a:r>
+                        <a:rPr sz="1000">
+                          <a:solidFill>
+                            <a:srgbClr val="262B2F"/>
+                          </a:solidFill>
+                          <a:latin typeface="Arial"/>
+                        </a:rPr>
+                        <a:t>189 MB</a:t>
+                      </a:r>
+                    </a:p>
+                  </a:txBody>
+                  <a:tcPr anchor="ctr" marT="12700" marB="12700" marL="63500" marR="63500">
+                    <a:solidFill>
+                      <a:srgbClr val="FFFFFF"/>
+                    </a:solidFill>
+                  </a:tcPr>
+                </a:tc>
+              </a:tr>
+              <a:tr h="205740">
+                <a:tc>
+                  <a:txBody>
+                    <a:bodyPr wrap="square"/>
+                    <a:lstStyle/>
+                    <a:p>
+                      <a:r>
+                        <a:rPr sz="1000">
+                          <a:solidFill>
+                            <a:srgbClr val="262B2F"/>
+                          </a:solidFill>
+                          <a:latin typeface="Arial"/>
+                        </a:rPr>
+                        <a:t>corr=0.75, k=None</a:t>
+                      </a:r>
+                    </a:p>
+                  </a:txBody>
+                  <a:tcPr anchor="ctr" marT="12700" marB="12700" marL="63500" marR="63500">
+                    <a:solidFill>
+                      <a:srgbClr val="FFFFFF"/>
+                    </a:solidFill>
+                  </a:tcPr>
+                </a:tc>
+                <a:tc>
+                  <a:txBody>
+                    <a:bodyPr wrap="square"/>
+                    <a:lstStyle/>
+                    <a:p>
+                      <a:r>
+                        <a:rPr sz="1000">
+                          <a:solidFill>
+                            <a:srgbClr val="262B2F"/>
+                          </a:solidFill>
+                          <a:latin typeface="Arial"/>
+                        </a:rPr>
+                        <a:t>1440.3</a:t>
+                      </a:r>
+                    </a:p>
+                  </a:txBody>
+                  <a:tcPr anchor="ctr" marT="12700" marB="12700" marL="63500" marR="63500">
+                    <a:solidFill>
+                      <a:srgbClr val="FFFFFF"/>
+                    </a:solidFill>
+                  </a:tcPr>
+                </a:tc>
+                <a:tc>
+                  <a:txBody>
+                    <a:bodyPr wrap="square"/>
+                    <a:lstStyle/>
+                    <a:p>
+                      <a:r>
+                        <a:rPr sz="1000">
+                          <a:solidFill>
+                            <a:srgbClr val="262B2F"/>
+                          </a:solidFill>
+                          <a:latin typeface="Arial"/>
+                        </a:rPr>
+                        <a:t>26.6</a:t>
+                      </a:r>
+                    </a:p>
+                  </a:txBody>
+                  <a:tcPr anchor="ctr" marT="12700" marB="12700" marL="63500" marR="63500">
+                    <a:solidFill>
+                      <a:srgbClr val="FFFFFF"/>
+                    </a:solidFill>
+                  </a:tcPr>
+                </a:tc>
+                <a:tc>
+                  <a:txBody>
+                    <a:bodyPr wrap="square"/>
+                    <a:lstStyle/>
+                    <a:p>
+                      <a:r>
+                        <a:rPr sz="1000">
+                          <a:solidFill>
+                            <a:srgbClr val="262B2F"/>
+                          </a:solidFill>
+                          <a:latin typeface="Arial"/>
+                        </a:rPr>
+                        <a:t>54.2×</a:t>
+                      </a:r>
+                    </a:p>
+                  </a:txBody>
+                  <a:tcPr anchor="ctr" marT="12700" marB="12700" marL="63500" marR="63500">
+                    <a:solidFill>
+                      <a:srgbClr val="FFFFFF"/>
+                    </a:solidFill>
+                  </a:tcPr>
+                </a:tc>
+                <a:tc>
+                  <a:txBody>
+                    <a:bodyPr wrap="square"/>
+                    <a:lstStyle/>
+                    <a:p>
+                      <a:r>
+                        <a:rPr sz="1000">
+                          <a:solidFill>
+                            <a:srgbClr val="262B2F"/>
+                          </a:solidFill>
+                          <a:latin typeface="Arial"/>
+                        </a:rPr>
+                        <a:t>189 MB</a:t>
+                      </a:r>
+                    </a:p>
+                  </a:txBody>
+                  <a:tcPr anchor="ctr" marT="12700" marB="12700" marL="63500" marR="63500">
+                    <a:solidFill>
+                      <a:srgbClr val="FFFFFF"/>
+                    </a:solidFill>
+                  </a:tcPr>
+                </a:tc>
+              </a:tr>
+              <a:tr h="205740">
+                <a:tc>
+                  <a:txBody>
+                    <a:bodyPr wrap="square"/>
+                    <a:lstStyle/>
+                    <a:p>
+                      <a:r>
+                        <a:rPr sz="1000">
+                          <a:solidFill>
+                            <a:srgbClr val="262B2F"/>
+                          </a:solidFill>
+                          <a:latin typeface="Arial"/>
+                        </a:rPr>
+                        <a:t>corr=0.90, k=30</a:t>
+                      </a:r>
+                    </a:p>
+                  </a:txBody>
+                  <a:tcPr anchor="ctr" marT="12700" marB="12700" marL="63500" marR="63500">
+                    <a:solidFill>
+                      <a:srgbClr val="FFFFFF"/>
+                    </a:solidFill>
+                  </a:tcPr>
+                </a:tc>
+                <a:tc>
+                  <a:txBody>
+                    <a:bodyPr wrap="square"/>
+                    <a:lstStyle/>
+                    <a:p>
+                      <a:r>
+                        <a:rPr sz="1000">
+                          <a:solidFill>
+                            <a:srgbClr val="262B2F"/>
+                          </a:solidFill>
+                          <a:latin typeface="Arial"/>
+                        </a:rPr>
+                        <a:t>964.1</a:t>
+                      </a:r>
+                    </a:p>
+                  </a:txBody>
+                  <a:tcPr anchor="ctr" marT="12700" marB="12700" marL="63500" marR="63500">
+                    <a:solidFill>
+                      <a:srgbClr val="FFFFFF"/>
+                    </a:solidFill>
+                  </a:tcPr>
+                </a:tc>
+                <a:tc>
+                  <a:txBody>
+                    <a:bodyPr wrap="square"/>
+                    <a:lstStyle/>
+                    <a:p>
+                      <a:r>
+                        <a:rPr sz="1000">
+                          <a:solidFill>
+                            <a:srgbClr val="262B2F"/>
+                          </a:solidFill>
+                          <a:latin typeface="Arial"/>
+                        </a:rPr>
+                        <a:t>25.7</a:t>
+                      </a:r>
+                    </a:p>
+                  </a:txBody>
+                  <a:tcPr anchor="ctr" marT="12700" marB="12700" marL="63500" marR="63500">
+                    <a:solidFill>
+                      <a:srgbClr val="FFFFFF"/>
+                    </a:solidFill>
+                  </a:tcPr>
+                </a:tc>
+                <a:tc>
+                  <a:txBody>
+                    <a:bodyPr wrap="square"/>
+                    <a:lstStyle/>
+                    <a:p>
+                      <a:r>
+                        <a:rPr sz="1000">
+                          <a:solidFill>
+                            <a:srgbClr val="262B2F"/>
+                          </a:solidFill>
+                          <a:latin typeface="Arial"/>
+                        </a:rPr>
+                        <a:t>37.5×</a:t>
+                      </a:r>
+                    </a:p>
+                  </a:txBody>
+                  <a:tcPr anchor="ctr" marT="12700" marB="12700" marL="63500" marR="63500">
+                    <a:solidFill>
+                      <a:srgbClr val="FFFFFF"/>
+                    </a:solidFill>
+                  </a:tcPr>
+                </a:tc>
+                <a:tc>
+                  <a:txBody>
+                    <a:bodyPr wrap="square"/>
+                    <a:lstStyle/>
+                    <a:p>
+                      <a:r>
+                        <a:rPr sz="1000">
+                          <a:solidFill>
+                            <a:srgbClr val="262B2F"/>
+                          </a:solidFill>
+                          <a:latin typeface="Arial"/>
+                        </a:rPr>
+                        <a:t>176 MB</a:t>
+                      </a:r>
+                    </a:p>
+                  </a:txBody>
+                  <a:tcPr anchor="ctr" marT="12700" marB="12700" marL="63500" marR="63500">
+                    <a:solidFill>
+                      <a:srgbClr val="FFFFFF"/>
+                    </a:solidFill>
+                  </a:tcPr>
+                </a:tc>
+              </a:tr>
+              <a:tr h="205740">
+                <a:tc>
+                  <a:txBody>
+                    <a:bodyPr wrap="square"/>
+                    <a:lstStyle/>
+                    <a:p>
+                      <a:r>
+                        <a:rPr sz="1000">
+                          <a:solidFill>
+                            <a:srgbClr val="262B2F"/>
+                          </a:solidFill>
+                          <a:latin typeface="Arial"/>
+                        </a:rPr>
+                        <a:t>corr=0.90, k=50</a:t>
+                      </a:r>
+                    </a:p>
+                  </a:txBody>
+                  <a:tcPr anchor="ctr" marT="12700" marB="12700" marL="63500" marR="63500">
+                    <a:solidFill>
+                      <a:srgbClr val="FFFFFF"/>
+                    </a:solidFill>
+                  </a:tcPr>
+                </a:tc>
+                <a:tc>
+                  <a:txBody>
+                    <a:bodyPr wrap="square"/>
+                    <a:lstStyle/>
+                    <a:p>
+                      <a:r>
+                        <a:rPr sz="1000">
+                          <a:solidFill>
+                            <a:srgbClr val="262B2F"/>
+                          </a:solidFill>
+                          <a:latin typeface="Arial"/>
+                        </a:rPr>
+                        <a:t>1453.8</a:t>
+                      </a:r>
+                    </a:p>
+                  </a:txBody>
+                  <a:tcPr anchor="ctr" marT="12700" marB="12700" marL="63500" marR="63500">
+                    <a:solidFill>
+                      <a:srgbClr val="FFFFFF"/>
+                    </a:solidFill>
+                  </a:tcPr>
+                </a:tc>
+                <a:tc>
+                  <a:txBody>
+                    <a:bodyPr wrap="square"/>
+                    <a:lstStyle/>
+                    <a:p>
+                      <a:r>
+                        <a:rPr sz="1000">
+                          <a:solidFill>
+                            <a:srgbClr val="262B2F"/>
+                          </a:solidFill>
+                          <a:latin typeface="Arial"/>
+                        </a:rPr>
+                        <a:t>26.4</a:t>
+                      </a:r>
+                    </a:p>
+                  </a:txBody>
+                  <a:tcPr anchor="ctr" marT="12700" marB="12700" marL="63500" marR="63500">
+                    <a:solidFill>
+                      <a:srgbClr val="FFFFFF"/>
+                    </a:solidFill>
+                  </a:tcPr>
+                </a:tc>
+                <a:tc>
+                  <a:txBody>
+                    <a:bodyPr wrap="square"/>
+                    <a:lstStyle/>
+                    <a:p>
+                      <a:r>
+                        <a:rPr sz="1000">
+                          <a:solidFill>
+                            <a:srgbClr val="262B2F"/>
+                          </a:solidFill>
+                          <a:latin typeface="Arial"/>
+                        </a:rPr>
+                        <a:t>55.1×</a:t>
+                      </a:r>
+                    </a:p>
+                  </a:txBody>
+                  <a:tcPr anchor="ctr" marT="12700" marB="12700" marL="63500" marR="63500">
+                    <a:solidFill>
+                      <a:srgbClr val="FFFFFF"/>
+                    </a:solidFill>
+                  </a:tcPr>
+                </a:tc>
+                <a:tc>
+                  <a:txBody>
+                    <a:bodyPr wrap="square"/>
+                    <a:lstStyle/>
+                    <a:p>
+                      <a:r>
+                        <a:rPr sz="1000">
+                          <a:solidFill>
+                            <a:srgbClr val="262B2F"/>
+                          </a:solidFill>
+                          <a:latin typeface="Arial"/>
+                        </a:rPr>
+                        <a:t>187 MB</a:t>
+                      </a:r>
+                    </a:p>
+                  </a:txBody>
+                  <a:tcPr anchor="ctr" marT="12700" marB="12700" marL="63500" marR="63500">
+                    <a:solidFill>
+                      <a:srgbClr val="FFFFFF"/>
+                    </a:solidFill>
+                  </a:tcPr>
+                </a:tc>
+              </a:tr>
+              <a:tr h="205740">
+                <a:tc>
+                  <a:txBody>
+                    <a:bodyPr wrap="square"/>
+                    <a:lstStyle/>
+                    <a:p>
+                      <a:r>
+                        <a:rPr sz="1000">
+                          <a:solidFill>
+                            <a:srgbClr val="262B2F"/>
+                          </a:solidFill>
+                          <a:latin typeface="Arial"/>
+                        </a:rPr>
+                        <a:t>corr=0.90, k=None</a:t>
+                      </a:r>
+                    </a:p>
+                  </a:txBody>
+                  <a:tcPr anchor="ctr" marT="12700" marB="12700" marL="63500" marR="63500">
+                    <a:solidFill>
+                      <a:srgbClr val="FFFFFF"/>
+                    </a:solidFill>
+                  </a:tcPr>
+                </a:tc>
+                <a:tc>
+                  <a:txBody>
+                    <a:bodyPr wrap="square"/>
+                    <a:lstStyle/>
+                    <a:p>
+                      <a:r>
+                        <a:rPr sz="1000">
+                          <a:solidFill>
+                            <a:srgbClr val="262B2F"/>
+                          </a:solidFill>
+                          <a:latin typeface="Arial"/>
+                        </a:rPr>
+                        <a:t>2223.6</a:t>
+                      </a:r>
+                    </a:p>
+                  </a:txBody>
+                  <a:tcPr anchor="ctr" marT="12700" marB="12700" marL="63500" marR="63500">
+                    <a:solidFill>
+                      <a:srgbClr val="FFFFFF"/>
+                    </a:solidFill>
+                  </a:tcPr>
+                </a:tc>
+                <a:tc>
+                  <a:txBody>
+                    <a:bodyPr wrap="square"/>
+                    <a:lstStyle/>
+                    <a:p>
+                      <a:r>
+                        <a:rPr sz="1000">
+                          <a:solidFill>
+                            <a:srgbClr val="262B2F"/>
+                          </a:solidFill>
+                          <a:latin typeface="Arial"/>
+                        </a:rPr>
+                        <a:t>28.2</a:t>
+                      </a:r>
+                    </a:p>
+                  </a:txBody>
+                  <a:tcPr anchor="ctr" marT="12700" marB="12700" marL="63500" marR="63500">
+                    <a:solidFill>
+                      <a:srgbClr val="FFFFFF"/>
+                    </a:solidFill>
+                  </a:tcPr>
+                </a:tc>
+                <a:tc>
+                  <a:txBody>
+                    <a:bodyPr wrap="square"/>
+                    <a:lstStyle/>
+                    <a:p>
+                      <a:r>
+                        <a:rPr sz="1000">
+                          <a:solidFill>
+                            <a:srgbClr val="262B2F"/>
+                          </a:solidFill>
+                          <a:latin typeface="Arial"/>
+                        </a:rPr>
+                        <a:t>78.8×</a:t>
+                      </a:r>
+                    </a:p>
+                  </a:txBody>
+                  <a:tcPr anchor="ctr" marT="12700" marB="12700" marL="63500" marR="63500">
+                    <a:solidFill>
+                      <a:srgbClr val="FFFFFF"/>
+                    </a:solidFill>
+                  </a:tcPr>
+                </a:tc>
+                <a:tc>
+                  <a:txBody>
+                    <a:bodyPr wrap="square"/>
+                    <a:lstStyle/>
+                    <a:p>
+                      <a:r>
+                        <a:rPr sz="1000">
+                          <a:solidFill>
+                            <a:srgbClr val="262B2F"/>
+                          </a:solidFill>
+                          <a:latin typeface="Arial"/>
+                        </a:rPr>
+                        <a:t>189 MB</a:t>
+                      </a:r>
+                    </a:p>
+                  </a:txBody>
+                  <a:tcPr anchor="ctr" marT="12700" marB="12700" marL="63500" marR="63500">
+                    <a:solidFill>
+                      <a:srgbClr val="FFFFFF"/>
+                    </a:solidFill>
+                  </a:tcPr>
+                </a:tc>
+              </a:tr>
+              <a:tr h="205740">
+                <a:tc>
+                  <a:txBody>
+                    <a:bodyPr wrap="square"/>
+                    <a:lstStyle/>
+                    <a:p>
+                      <a:r>
+                        <a:rPr sz="1000">
+                          <a:solidFill>
+                            <a:srgbClr val="262B2F"/>
+                          </a:solidFill>
+                          <a:latin typeface="Arial"/>
+                        </a:rPr>
+                        <a:t>corr=None, k=30</a:t>
+                      </a:r>
+                    </a:p>
+                  </a:txBody>
+                  <a:tcPr anchor="ctr" marT="12700" marB="12700" marL="63500" marR="63500">
+                    <a:solidFill>
+                      <a:srgbClr val="FFFFFF"/>
+                    </a:solidFill>
+                  </a:tcPr>
+                </a:tc>
+                <a:tc>
+                  <a:txBody>
+                    <a:bodyPr wrap="square"/>
+                    <a:lstStyle/>
+                    <a:p>
+                      <a:r>
+                        <a:rPr sz="1000">
+                          <a:solidFill>
+                            <a:srgbClr val="262B2F"/>
+                          </a:solidFill>
+                          <a:latin typeface="Arial"/>
+                        </a:rPr>
+                        <a:t>1003.6</a:t>
+                      </a:r>
+                    </a:p>
+                  </a:txBody>
+                  <a:tcPr anchor="ctr" marT="12700" marB="12700" marL="63500" marR="63500">
+                    <a:solidFill>
+                      <a:srgbClr val="FFFFFF"/>
+                    </a:solidFill>
+                  </a:tcPr>
+                </a:tc>
+                <a:tc>
+                  <a:txBody>
+                    <a:bodyPr wrap="square"/>
+                    <a:lstStyle/>
+                    <a:p>
+                      <a:r>
+                        <a:rPr sz="1000">
+                          <a:solidFill>
+                            <a:srgbClr val="262B2F"/>
+                          </a:solidFill>
+                          <a:latin typeface="Arial"/>
+                        </a:rPr>
+                        <a:t>21.1</a:t>
+                      </a:r>
+                    </a:p>
+                  </a:txBody>
+                  <a:tcPr anchor="ctr" marT="12700" marB="12700" marL="63500" marR="63500">
+                    <a:solidFill>
+                      <a:srgbClr val="FFFFFF"/>
+                    </a:solidFill>
+                  </a:tcPr>
+                </a:tc>
+                <a:tc>
+                  <a:txBody>
+                    <a:bodyPr wrap="square"/>
+                    <a:lstStyle/>
+                    <a:p>
+                      <a:r>
+                        <a:rPr sz="1000">
+                          <a:solidFill>
+                            <a:srgbClr val="262B2F"/>
+                          </a:solidFill>
+                          <a:latin typeface="Arial"/>
+                        </a:rPr>
+                        <a:t>47.7×</a:t>
+                      </a:r>
+                    </a:p>
+                  </a:txBody>
+                  <a:tcPr anchor="ctr" marT="12700" marB="12700" marL="63500" marR="63500">
+                    <a:solidFill>
+                      <a:srgbClr val="FFFFFF"/>
+                    </a:solidFill>
+                  </a:tcPr>
+                </a:tc>
+                <a:tc>
+                  <a:txBody>
+                    <a:bodyPr wrap="square"/>
+                    <a:lstStyle/>
+                    <a:p>
+                      <a:r>
+                        <a:rPr sz="1000">
+                          <a:solidFill>
+                            <a:srgbClr val="262B2F"/>
+                          </a:solidFill>
+                          <a:latin typeface="Arial"/>
+                        </a:rPr>
+                        <a:t>177 MB</a:t>
+                      </a:r>
+                    </a:p>
+                  </a:txBody>
+                  <a:tcPr anchor="ctr" marT="12700" marB="12700" marL="63500" marR="63500">
+                    <a:solidFill>
+                      <a:srgbClr val="FFFFFF"/>
+                    </a:solidFill>
+                  </a:tcPr>
+                </a:tc>
+              </a:tr>
+              <a:tr h="205740">
+                <a:tc>
+                  <a:txBody>
+                    <a:bodyPr wrap="square"/>
+                    <a:lstStyle/>
+                    <a:p>
+                      <a:r>
+                        <a:rPr sz="1000">
+                          <a:solidFill>
+                            <a:srgbClr val="262B2F"/>
+                          </a:solidFill>
+                          <a:latin typeface="Arial"/>
+                        </a:rPr>
+                        <a:t>corr=None, k=50</a:t>
+                      </a:r>
+                    </a:p>
+                  </a:txBody>
+                  <a:tcPr anchor="ctr" marT="12700" marB="12700" marL="63500" marR="63500">
+                    <a:solidFill>
+                      <a:srgbClr val="FFFFFF"/>
+                    </a:solidFill>
+                  </a:tcPr>
+                </a:tc>
+                <a:tc>
+                  <a:txBody>
+                    <a:bodyPr wrap="square"/>
+                    <a:lstStyle/>
+                    <a:p>
+                      <a:r>
+                        <a:rPr sz="1000">
+                          <a:solidFill>
+                            <a:srgbClr val="262B2F"/>
+                          </a:solidFill>
+                          <a:latin typeface="Arial"/>
+                        </a:rPr>
+                        <a:t>1385.9</a:t>
+                      </a:r>
+                    </a:p>
+                  </a:txBody>
+                  <a:tcPr anchor="ctr" marT="12700" marB="12700" marL="63500" marR="63500">
+                    <a:solidFill>
+                      <a:srgbClr val="FFFFFF"/>
+                    </a:solidFill>
+                  </a:tcPr>
+                </a:tc>
+                <a:tc>
+                  <a:txBody>
+                    <a:bodyPr wrap="square"/>
+                    <a:lstStyle/>
+                    <a:p>
+                      <a:r>
+                        <a:rPr sz="1000">
+                          <a:solidFill>
+                            <a:srgbClr val="262B2F"/>
+                          </a:solidFill>
+                          <a:latin typeface="Arial"/>
+                        </a:rPr>
+                        <a:t>21.2</a:t>
+                      </a:r>
+                    </a:p>
+                  </a:txBody>
+                  <a:tcPr anchor="ctr" marT="12700" marB="12700" marL="63500" marR="63500">
+                    <a:solidFill>
+                      <a:srgbClr val="FFFFFF"/>
+                    </a:solidFill>
+                  </a:tcPr>
+                </a:tc>
+                <a:tc>
+                  <a:txBody>
+                    <a:bodyPr wrap="square"/>
+                    <a:lstStyle/>
+                    <a:p>
+                      <a:r>
+                        <a:rPr sz="1000">
+                          <a:solidFill>
+                            <a:srgbClr val="262B2F"/>
+                          </a:solidFill>
+                          <a:latin typeface="Arial"/>
+                        </a:rPr>
+                        <a:t>65.3×</a:t>
+                      </a:r>
+                    </a:p>
+                  </a:txBody>
+                  <a:tcPr anchor="ctr" marT="12700" marB="12700" marL="63500" marR="63500">
+                    <a:solidFill>
+                      <a:srgbClr val="FFFFFF"/>
+                    </a:solidFill>
+                  </a:tcPr>
+                </a:tc>
+                <a:tc>
+                  <a:txBody>
+                    <a:bodyPr wrap="square"/>
+                    <a:lstStyle/>
+                    <a:p>
+                      <a:r>
+                        <a:rPr sz="1000">
+                          <a:solidFill>
+                            <a:srgbClr val="262B2F"/>
+                          </a:solidFill>
+                          <a:latin typeface="Arial"/>
+                        </a:rPr>
+                        <a:t>178 MB</a:t>
+                      </a:r>
+                    </a:p>
+                  </a:txBody>
+                  <a:tcPr anchor="ctr" marT="12700" marB="12700" marL="63500" marR="63500">
+                    <a:solidFill>
+                      <a:srgbClr val="FFFFFF"/>
+                    </a:solidFill>
+                  </a:tcPr>
+                </a:tc>
+              </a:tr>
+              <a:tr h="205740">
+                <a:tc>
+                  <a:txBody>
+                    <a:bodyPr wrap="square"/>
+                    <a:lstStyle/>
+                    <a:p>
+                      <a:r>
+                        <a:rPr sz="1000" b="1">
+                          <a:solidFill>
+                            <a:srgbClr val="262B2F"/>
+                          </a:solidFill>
+                          <a:latin typeface="Arial"/>
+                        </a:rPr>
+                        <a:t>corr=None, k=None</a:t>
+                      </a:r>
+                    </a:p>
+                  </a:txBody>
+                  <a:tcPr anchor="ctr" marT="12700" marB="12700" marL="63500" marR="63500">
+                    <a:solidFill>
+                      <a:srgbClr val="FFE3C1"/>
+                    </a:solidFill>
+                  </a:tcPr>
+                </a:tc>
+                <a:tc>
+                  <a:txBody>
+                    <a:bodyPr wrap="square"/>
+                    <a:lstStyle/>
+                    <a:p>
+                      <a:r>
+                        <a:rPr sz="1000" b="1">
+                          <a:solidFill>
+                            <a:srgbClr val="262B2F"/>
+                          </a:solidFill>
+                          <a:latin typeface="Arial"/>
+                        </a:rPr>
+                        <a:t>3816.1</a:t>
+                      </a:r>
+                    </a:p>
+                  </a:txBody>
+                  <a:tcPr anchor="ctr" marT="12700" marB="12700" marL="63500" marR="63500">
+                    <a:solidFill>
+                      <a:srgbClr val="FFE3C1"/>
+                    </a:solidFill>
+                  </a:tcPr>
+                </a:tc>
+                <a:tc>
+                  <a:txBody>
+                    <a:bodyPr wrap="square"/>
+                    <a:lstStyle/>
+                    <a:p>
+                      <a:r>
+                        <a:rPr sz="1000" b="1">
+                          <a:solidFill>
+                            <a:srgbClr val="262B2F"/>
+                          </a:solidFill>
+                          <a:latin typeface="Arial"/>
+                        </a:rPr>
+                        <a:t>18.9</a:t>
+                      </a:r>
+                    </a:p>
+                  </a:txBody>
+                  <a:tcPr anchor="ctr" marT="12700" marB="12700" marL="63500" marR="63500">
+                    <a:solidFill>
+                      <a:srgbClr val="FFE3C1"/>
+                    </a:solidFill>
+                  </a:tcPr>
+                </a:tc>
+                <a:tc>
+                  <a:txBody>
+                    <a:bodyPr wrap="square"/>
+                    <a:lstStyle/>
+                    <a:p>
+                      <a:r>
+                        <a:rPr sz="1000" b="1">
+                          <a:solidFill>
+                            <a:srgbClr val="262B2F"/>
+                          </a:solidFill>
+                          <a:latin typeface="Arial"/>
+                        </a:rPr>
+                        <a:t>202×</a:t>
+                      </a:r>
+                    </a:p>
+                  </a:txBody>
+                  <a:tcPr anchor="ctr" marT="12700" marB="12700" marL="63500" marR="63500">
+                    <a:solidFill>
+                      <a:srgbClr val="FFE3C1"/>
+                    </a:solidFill>
+                  </a:tcPr>
+                </a:tc>
+                <a:tc>
+                  <a:txBody>
+                    <a:bodyPr wrap="square"/>
+                    <a:lstStyle/>
+                    <a:p>
+                      <a:r>
+                        <a:rPr sz="1000" b="1">
+                          <a:solidFill>
+                            <a:srgbClr val="262B2F"/>
+                          </a:solidFill>
+                          <a:latin typeface="Arial"/>
+                        </a:rPr>
+                        <a:t>188 MB</a:t>
+                      </a:r>
+                    </a:p>
+                  </a:txBody>
+                  <a:tcPr anchor="ctr" marT="12700" marB="12700" marL="63500" marR="63500">
+                    <a:solidFill>
+                      <a:srgbClr val="FFE3C1"/>
+                    </a:solidFill>
+                  </a:tcPr>
+                </a:tc>
+              </a:tr>
+            </a:tbl>
+          </a:graphicData>
+        </a:graphic>
+      </p:graphicFrame>
+      <p:sp>
+        <p:nvSpPr>
+          <p:cNvPr id="5" name="TextBox 4"/>
+          <p:cNvSpPr txBox="1"/>
+          <p:nvPr/>
+        </p:nvSpPr>
+        <p:spPr>
+          <a:xfrm>
+            <a:off x="822960" y="3886200"/>
+            <a:ext cx="10515600" cy="274320"/>
+          </a:xfrm>
+          <a:prstGeom prst="rect">
+            <a:avLst/>
+          </a:prstGeom>
+          <a:noFill/>
+        </p:spPr>
+        <p:txBody>
+          <a:bodyPr wrap="none">
+            <a:spAutoFit/>
+          </a:bodyPr>
+          <a:lstStyle/>
+          <a:p>
+            <a:r>
+              <a:rPr sz="1400" b="1">
+                <a:solidFill>
+                  <a:srgbClr val="FF9E1B"/>
+                </a:solidFill>
+              </a:rPr>
+              <a:t>Random Forest — median 11.6×, ~18.5 GB  (borderline viable)</a:t>
+            </a:r>
+          </a:p>
+        </p:txBody>
+      </p:sp>
+      <p:graphicFrame>
+        <p:nvGraphicFramePr>
+          <p:cNvPr id="6" name="Table 5"/>
+          <p:cNvGraphicFramePr>
+            <a:graphicFrameLocks noGrp="1"/>
+          </p:cNvGraphicFramePr>
+          <p:nvPr/>
+        </p:nvGraphicFramePr>
+        <p:xfrm>
+          <a:off x="822960" y="4178808"/>
+          <a:ext cx="10515600" cy="2057400"/>
+        </p:xfrm>
+        <a:graphic>
+          <a:graphicData uri="http://schemas.openxmlformats.org/drawingml/2006/table">
+            <a:tbl>
+              <a:tblPr firstRow="1" bandRow="1">
+                <a:tableStyleId>{5C22544A-7EE6-4342-B048-85BDC9FD1C3A}</a:tableStyleId>
+              </a:tblPr>
+              <a:tblGrid>
+                <a:gridCol w="3383280"/>
+                <a:gridCol w="1783080"/>
+                <a:gridCol w="1783080"/>
+                <a:gridCol w="1783080"/>
+                <a:gridCol w="1783080"/>
+              </a:tblGrid>
+              <a:tr h="205740">
+                <a:tc>
+                  <a:txBody>
+                    <a:bodyPr wrap="square"/>
+                    <a:lstStyle/>
+                    <a:p>
+                      <a:r>
+                        <a:rPr sz="1000" b="1">
+                          <a:solidFill>
+                            <a:srgbClr val="FFFFFF"/>
+                          </a:solidFill>
+                          <a:latin typeface="Arial"/>
+                        </a:rPr>
+                        <a:t>Config</a:t>
+                      </a:r>
+                    </a:p>
+                  </a:txBody>
+                  <a:tcPr anchor="ctr" marT="12700" marB="12700" marL="63500" marR="63500">
+                    <a:solidFill>
+                      <a:srgbClr val="FF9E1B"/>
+                    </a:solidFill>
+                  </a:tcPr>
+                </a:tc>
+                <a:tc>
+                  <a:txBody>
+                    <a:bodyPr wrap="square"/>
+                    <a:lstStyle/>
+                    <a:p>
+                      <a:r>
+                        <a:rPr sz="1000" b="1">
+                          <a:solidFill>
+                            <a:srgbClr val="FFFFFF"/>
+                          </a:solidFill>
+                          <a:latin typeface="Arial"/>
+                        </a:rPr>
+                        <a:t>Cold (s)</a:t>
+                      </a:r>
+                    </a:p>
+                  </a:txBody>
+                  <a:tcPr anchor="ctr" marT="12700" marB="12700" marL="63500" marR="63500">
+                    <a:solidFill>
+                      <a:srgbClr val="FF9E1B"/>
+                    </a:solidFill>
+                  </a:tcPr>
+                </a:tc>
+                <a:tc>
+                  <a:txBody>
+                    <a:bodyPr wrap="square"/>
+                    <a:lstStyle/>
+                    <a:p>
+                      <a:r>
+                        <a:rPr sz="1000" b="1">
+                          <a:solidFill>
+                            <a:srgbClr val="FFFFFF"/>
+                          </a:solidFill>
+                          <a:latin typeface="Arial"/>
+                        </a:rPr>
+                        <a:t>Warm (s)</a:t>
+                      </a:r>
+                    </a:p>
+                  </a:txBody>
+                  <a:tcPr anchor="ctr" marT="12700" marB="12700" marL="63500" marR="63500">
+                    <a:solidFill>
+                      <a:srgbClr val="FF9E1B"/>
+                    </a:solidFill>
+                  </a:tcPr>
+                </a:tc>
+                <a:tc>
+                  <a:txBody>
+                    <a:bodyPr wrap="square"/>
+                    <a:lstStyle/>
+                    <a:p>
+                      <a:r>
+                        <a:rPr sz="1000" b="1">
+                          <a:solidFill>
+                            <a:srgbClr val="FFFFFF"/>
+                          </a:solidFill>
+                          <a:latin typeface="Arial"/>
+                        </a:rPr>
+                        <a:t>Speedup</a:t>
+                      </a:r>
+                    </a:p>
+                  </a:txBody>
+                  <a:tcPr anchor="ctr" marT="12700" marB="12700" marL="63500" marR="63500">
+                    <a:solidFill>
+                      <a:srgbClr val="FF9E1B"/>
+                    </a:solidFill>
+                  </a:tcPr>
+                </a:tc>
+                <a:tc>
+                  <a:txBody>
+                    <a:bodyPr wrap="square"/>
+                    <a:lstStyle/>
+                    <a:p>
+                      <a:r>
+                        <a:rPr sz="1000" b="1">
+                          <a:solidFill>
+                            <a:srgbClr val="FFFFFF"/>
+                          </a:solidFill>
+                          <a:latin typeface="Arial"/>
+                        </a:rPr>
+                        <a:t>Cache</a:t>
+                      </a:r>
+                    </a:p>
+                  </a:txBody>
+                  <a:tcPr anchor="ctr" marT="12700" marB="12700" marL="63500" marR="63500">
+                    <a:solidFill>
+                      <a:srgbClr val="FF9E1B"/>
+                    </a:solidFill>
+                  </a:tcPr>
+                </a:tc>
+              </a:tr>
+              <a:tr h="205740">
+                <a:tc>
+                  <a:txBody>
+                    <a:bodyPr wrap="square"/>
+                    <a:lstStyle/>
+                    <a:p>
+                      <a:r>
+                        <a:rPr sz="1000">
+                          <a:solidFill>
+                            <a:srgbClr val="262B2F"/>
+                          </a:solidFill>
+                          <a:latin typeface="Arial"/>
+                        </a:rPr>
+                        <a:t>corr=0.75, k=30</a:t>
+                      </a:r>
+                    </a:p>
+                  </a:txBody>
+                  <a:tcPr anchor="ctr" marT="12700" marB="12700" marL="63500" marR="63500">
+                    <a:solidFill>
+                      <a:srgbClr val="FFFFFF"/>
+                    </a:solidFill>
+                  </a:tcPr>
+                </a:tc>
+                <a:tc>
+                  <a:txBody>
+                    <a:bodyPr wrap="square"/>
+                    <a:lstStyle/>
+                    <a:p>
+                      <a:r>
+                        <a:rPr sz="1000">
+                          <a:solidFill>
+                            <a:srgbClr val="262B2F"/>
+                          </a:solidFill>
+                          <a:latin typeface="Arial"/>
+                        </a:rPr>
+                        <a:t>4341.3</a:t>
+                      </a:r>
+                    </a:p>
+                  </a:txBody>
+                  <a:tcPr anchor="ctr" marT="12700" marB="12700" marL="63500" marR="63500">
+                    <a:solidFill>
+                      <a:srgbClr val="FFFFFF"/>
+                    </a:solidFill>
+                  </a:tcPr>
+                </a:tc>
+                <a:tc>
+                  <a:txBody>
+                    <a:bodyPr wrap="square"/>
+                    <a:lstStyle/>
+                    <a:p>
+                      <a:r>
+                        <a:rPr sz="1000">
+                          <a:solidFill>
+                            <a:srgbClr val="262B2F"/>
+                          </a:solidFill>
+                          <a:latin typeface="Arial"/>
+                        </a:rPr>
+                        <a:t>391.8</a:t>
+                      </a:r>
+                    </a:p>
+                  </a:txBody>
+                  <a:tcPr anchor="ctr" marT="12700" marB="12700" marL="63500" marR="63500">
+                    <a:solidFill>
+                      <a:srgbClr val="FFFFFF"/>
+                    </a:solidFill>
+                  </a:tcPr>
+                </a:tc>
+                <a:tc>
+                  <a:txBody>
+                    <a:bodyPr wrap="square"/>
+                    <a:lstStyle/>
+                    <a:p>
+                      <a:r>
+                        <a:rPr sz="1000">
+                          <a:solidFill>
+                            <a:srgbClr val="262B2F"/>
+                          </a:solidFill>
+                          <a:latin typeface="Arial"/>
+                        </a:rPr>
+                        <a:t>11.1×</a:t>
+                      </a:r>
+                    </a:p>
+                  </a:txBody>
+                  <a:tcPr anchor="ctr" marT="12700" marB="12700" marL="63500" marR="63500">
+                    <a:solidFill>
+                      <a:srgbClr val="FFFFFF"/>
+                    </a:solidFill>
+                  </a:tcPr>
+                </a:tc>
+                <a:tc>
+                  <a:txBody>
+                    <a:bodyPr wrap="square"/>
+                    <a:lstStyle/>
+                    <a:p>
+                      <a:r>
+                        <a:rPr sz="1000">
+                          <a:solidFill>
+                            <a:srgbClr val="262B2F"/>
+                          </a:solidFill>
+                          <a:latin typeface="Arial"/>
+                        </a:rPr>
+                        <a:t>19.2 GB</a:t>
+                      </a:r>
+                    </a:p>
+                  </a:txBody>
+                  <a:tcPr anchor="ctr" marT="12700" marB="12700" marL="63500" marR="63500">
+                    <a:solidFill>
+                      <a:srgbClr val="FFFFFF"/>
+                    </a:solidFill>
+                  </a:tcPr>
+                </a:tc>
+              </a:tr>
+              <a:tr h="205740">
+                <a:tc>
+                  <a:txBody>
+                    <a:bodyPr wrap="square"/>
+                    <a:lstStyle/>
+                    <a:p>
+                      <a:r>
+                        <a:rPr sz="1000">
+                          <a:solidFill>
+                            <a:srgbClr val="262B2F"/>
+                          </a:solidFill>
+                          <a:latin typeface="Arial"/>
+                        </a:rPr>
+                        <a:t>corr=0.75, k=50</a:t>
+                      </a:r>
+                    </a:p>
+                  </a:txBody>
+                  <a:tcPr anchor="ctr" marT="12700" marB="12700" marL="63500" marR="63500">
+                    <a:solidFill>
+                      <a:srgbClr val="FFFFFF"/>
+                    </a:solidFill>
+                  </a:tcPr>
+                </a:tc>
+                <a:tc>
+                  <a:txBody>
+                    <a:bodyPr wrap="square"/>
+                    <a:lstStyle/>
+                    <a:p>
+                      <a:r>
+                        <a:rPr sz="1000">
+                          <a:solidFill>
+                            <a:srgbClr val="262B2F"/>
+                          </a:solidFill>
+                          <a:latin typeface="Arial"/>
+                        </a:rPr>
+                        <a:t>4638.0</a:t>
+                      </a:r>
+                    </a:p>
+                  </a:txBody>
+                  <a:tcPr anchor="ctr" marT="12700" marB="12700" marL="63500" marR="63500">
+                    <a:solidFill>
+                      <a:srgbClr val="FFFFFF"/>
+                    </a:solidFill>
+                  </a:tcPr>
+                </a:tc>
+                <a:tc>
+                  <a:txBody>
+                    <a:bodyPr wrap="square"/>
+                    <a:lstStyle/>
+                    <a:p>
+                      <a:r>
+                        <a:rPr sz="1000">
+                          <a:solidFill>
+                            <a:srgbClr val="262B2F"/>
+                          </a:solidFill>
+                          <a:latin typeface="Arial"/>
+                        </a:rPr>
+                        <a:t>402.8</a:t>
+                      </a:r>
+                    </a:p>
+                  </a:txBody>
+                  <a:tcPr anchor="ctr" marT="12700" marB="12700" marL="63500" marR="63500">
+                    <a:solidFill>
+                      <a:srgbClr val="FFFFFF"/>
+                    </a:solidFill>
+                  </a:tcPr>
+                </a:tc>
+                <a:tc>
+                  <a:txBody>
+                    <a:bodyPr wrap="square"/>
+                    <a:lstStyle/>
+                    <a:p>
+                      <a:r>
+                        <a:rPr sz="1000">
+                          <a:solidFill>
+                            <a:srgbClr val="262B2F"/>
+                          </a:solidFill>
+                          <a:latin typeface="Arial"/>
+                        </a:rPr>
+                        <a:t>11.5×</a:t>
+                      </a:r>
+                    </a:p>
+                  </a:txBody>
+                  <a:tcPr anchor="ctr" marT="12700" marB="12700" marL="63500" marR="63500">
+                    <a:solidFill>
+                      <a:srgbClr val="FFFFFF"/>
+                    </a:solidFill>
+                  </a:tcPr>
+                </a:tc>
+                <a:tc>
+                  <a:txBody>
+                    <a:bodyPr wrap="square"/>
+                    <a:lstStyle/>
+                    <a:p>
+                      <a:r>
+                        <a:rPr sz="1000">
+                          <a:solidFill>
+                            <a:srgbClr val="262B2F"/>
+                          </a:solidFill>
+                          <a:latin typeface="Arial"/>
+                        </a:rPr>
+                        <a:t>19.9 GB</a:t>
+                      </a:r>
+                    </a:p>
+                  </a:txBody>
+                  <a:tcPr anchor="ctr" marT="12700" marB="12700" marL="63500" marR="63500">
+                    <a:solidFill>
+                      <a:srgbClr val="FFFFFF"/>
+                    </a:solidFill>
+                  </a:tcPr>
+                </a:tc>
+              </a:tr>
+              <a:tr h="205740">
+                <a:tc>
+                  <a:txBody>
+                    <a:bodyPr wrap="square"/>
+                    <a:lstStyle/>
+                    <a:p>
+                      <a:r>
+                        <a:rPr sz="1000">
+                          <a:solidFill>
+                            <a:srgbClr val="262B2F"/>
+                          </a:solidFill>
+                          <a:latin typeface="Arial"/>
+                        </a:rPr>
+                        <a:t>corr=0.75, k=None</a:t>
+                      </a:r>
+                    </a:p>
+                  </a:txBody>
+                  <a:tcPr anchor="ctr" marT="12700" marB="12700" marL="63500" marR="63500">
+                    <a:solidFill>
+                      <a:srgbClr val="FFFFFF"/>
+                    </a:solidFill>
+                  </a:tcPr>
+                </a:tc>
+                <a:tc>
+                  <a:txBody>
+                    <a:bodyPr wrap="square"/>
+                    <a:lstStyle/>
+                    <a:p>
+                      <a:r>
+                        <a:rPr sz="1000">
+                          <a:solidFill>
+                            <a:srgbClr val="262B2F"/>
+                          </a:solidFill>
+                          <a:latin typeface="Arial"/>
+                        </a:rPr>
+                        <a:t>4648.3</a:t>
+                      </a:r>
+                    </a:p>
+                  </a:txBody>
+                  <a:tcPr anchor="ctr" marT="12700" marB="12700" marL="63500" marR="63500">
+                    <a:solidFill>
+                      <a:srgbClr val="FFFFFF"/>
+                    </a:solidFill>
+                  </a:tcPr>
+                </a:tc>
+                <a:tc>
+                  <a:txBody>
+                    <a:bodyPr wrap="square"/>
+                    <a:lstStyle/>
+                    <a:p>
+                      <a:r>
+                        <a:rPr sz="1000">
+                          <a:solidFill>
+                            <a:srgbClr val="262B2F"/>
+                          </a:solidFill>
+                          <a:latin typeface="Arial"/>
+                        </a:rPr>
+                        <a:t>401.3</a:t>
+                      </a:r>
+                    </a:p>
+                  </a:txBody>
+                  <a:tcPr anchor="ctr" marT="12700" marB="12700" marL="63500" marR="63500">
+                    <a:solidFill>
+                      <a:srgbClr val="FFFFFF"/>
+                    </a:solidFill>
+                  </a:tcPr>
+                </a:tc>
+                <a:tc>
+                  <a:txBody>
+                    <a:bodyPr wrap="square"/>
+                    <a:lstStyle/>
+                    <a:p>
+                      <a:r>
+                        <a:rPr sz="1000">
+                          <a:solidFill>
+                            <a:srgbClr val="262B2F"/>
+                          </a:solidFill>
+                          <a:latin typeface="Arial"/>
+                        </a:rPr>
+                        <a:t>11.6×</a:t>
+                      </a:r>
+                    </a:p>
+                  </a:txBody>
+                  <a:tcPr anchor="ctr" marT="12700" marB="12700" marL="63500" marR="63500">
+                    <a:solidFill>
+                      <a:srgbClr val="FFFFFF"/>
+                    </a:solidFill>
+                  </a:tcPr>
+                </a:tc>
+                <a:tc>
+                  <a:txBody>
+                    <a:bodyPr wrap="square"/>
+                    <a:lstStyle/>
+                    <a:p>
+                      <a:r>
+                        <a:rPr sz="1000">
+                          <a:solidFill>
+                            <a:srgbClr val="262B2F"/>
+                          </a:solidFill>
+                          <a:latin typeface="Arial"/>
+                        </a:rPr>
+                        <a:t>19.9 GB</a:t>
+                      </a:r>
+                    </a:p>
+                  </a:txBody>
+                  <a:tcPr anchor="ctr" marT="12700" marB="12700" marL="63500" marR="63500">
+                    <a:solidFill>
+                      <a:srgbClr val="FFFFFF"/>
+                    </a:solidFill>
+                  </a:tcPr>
+                </a:tc>
+              </a:tr>
+              <a:tr h="205740">
+                <a:tc>
+                  <a:txBody>
+                    <a:bodyPr wrap="square"/>
+                    <a:lstStyle/>
+                    <a:p>
+                      <a:r>
+                        <a:rPr sz="1000">
+                          <a:solidFill>
+                            <a:srgbClr val="262B2F"/>
+                          </a:solidFill>
+                          <a:latin typeface="Arial"/>
+                        </a:rPr>
+                        <a:t>corr=0.90, k=30</a:t>
+                      </a:r>
+                    </a:p>
+                  </a:txBody>
+                  <a:tcPr anchor="ctr" marT="12700" marB="12700" marL="63500" marR="63500">
+                    <a:solidFill>
+                      <a:srgbClr val="FFFFFF"/>
+                    </a:solidFill>
+                  </a:tcPr>
+                </a:tc>
+                <a:tc>
+                  <a:txBody>
+                    <a:bodyPr wrap="square"/>
+                    <a:lstStyle/>
+                    <a:p>
+                      <a:r>
+                        <a:rPr sz="1000">
+                          <a:solidFill>
+                            <a:srgbClr val="262B2F"/>
+                          </a:solidFill>
+                          <a:latin typeface="Arial"/>
+                        </a:rPr>
+                        <a:t>4342.7</a:t>
+                      </a:r>
+                    </a:p>
+                  </a:txBody>
+                  <a:tcPr anchor="ctr" marT="12700" marB="12700" marL="63500" marR="63500">
+                    <a:solidFill>
+                      <a:srgbClr val="FFFFFF"/>
+                    </a:solidFill>
+                  </a:tcPr>
+                </a:tc>
+                <a:tc>
+                  <a:txBody>
+                    <a:bodyPr wrap="square"/>
+                    <a:lstStyle/>
+                    <a:p>
+                      <a:r>
+                        <a:rPr sz="1000">
+                          <a:solidFill>
+                            <a:srgbClr val="262B2F"/>
+                          </a:solidFill>
+                          <a:latin typeface="Arial"/>
+                        </a:rPr>
+                        <a:t>392.2</a:t>
+                      </a:r>
+                    </a:p>
+                  </a:txBody>
+                  <a:tcPr anchor="ctr" marT="12700" marB="12700" marL="63500" marR="63500">
+                    <a:solidFill>
+                      <a:srgbClr val="FFFFFF"/>
+                    </a:solidFill>
+                  </a:tcPr>
+                </a:tc>
+                <a:tc>
+                  <a:txBody>
+                    <a:bodyPr wrap="square"/>
+                    <a:lstStyle/>
+                    <a:p>
+                      <a:r>
+                        <a:rPr sz="1000">
+                          <a:solidFill>
+                            <a:srgbClr val="262B2F"/>
+                          </a:solidFill>
+                          <a:latin typeface="Arial"/>
+                        </a:rPr>
+                        <a:t>11.1×</a:t>
+                      </a:r>
+                    </a:p>
+                  </a:txBody>
+                  <a:tcPr anchor="ctr" marT="12700" marB="12700" marL="63500" marR="63500">
+                    <a:solidFill>
+                      <a:srgbClr val="FFFFFF"/>
+                    </a:solidFill>
+                  </a:tcPr>
+                </a:tc>
+                <a:tc>
+                  <a:txBody>
+                    <a:bodyPr wrap="square"/>
+                    <a:lstStyle/>
+                    <a:p>
+                      <a:r>
+                        <a:rPr sz="1000">
+                          <a:solidFill>
+                            <a:srgbClr val="262B2F"/>
+                          </a:solidFill>
+                          <a:latin typeface="Arial"/>
+                        </a:rPr>
+                        <a:t>19.1 GB</a:t>
+                      </a:r>
+                    </a:p>
+                  </a:txBody>
+                  <a:tcPr anchor="ctr" marT="12700" marB="12700" marL="63500" marR="63500">
+                    <a:solidFill>
+                      <a:srgbClr val="FFFFFF"/>
+                    </a:solidFill>
+                  </a:tcPr>
+                </a:tc>
+              </a:tr>
+              <a:tr h="205740">
+                <a:tc>
+                  <a:txBody>
+                    <a:bodyPr wrap="square"/>
+                    <a:lstStyle/>
+                    <a:p>
+                      <a:r>
+                        <a:rPr sz="1000">
+                          <a:solidFill>
+                            <a:srgbClr val="262B2F"/>
+                          </a:solidFill>
+                          <a:latin typeface="Arial"/>
+                        </a:rPr>
+                        <a:t>corr=0.90, k=50</a:t>
+                      </a:r>
+                    </a:p>
+                  </a:txBody>
+                  <a:tcPr anchor="ctr" marT="12700" marB="12700" marL="63500" marR="63500">
+                    <a:solidFill>
+                      <a:srgbClr val="FFFFFF"/>
+                    </a:solidFill>
+                  </a:tcPr>
+                </a:tc>
+                <a:tc>
+                  <a:txBody>
+                    <a:bodyPr wrap="square"/>
+                    <a:lstStyle/>
+                    <a:p>
+                      <a:r>
+                        <a:rPr sz="1000">
+                          <a:solidFill>
+                            <a:srgbClr val="262B2F"/>
+                          </a:solidFill>
+                          <a:latin typeface="Arial"/>
+                        </a:rPr>
+                        <a:t>5794.2</a:t>
+                      </a:r>
+                    </a:p>
+                  </a:txBody>
+                  <a:tcPr anchor="ctr" marT="12700" marB="12700" marL="63500" marR="63500">
+                    <a:solidFill>
+                      <a:srgbClr val="FFFFFF"/>
+                    </a:solidFill>
+                  </a:tcPr>
+                </a:tc>
+                <a:tc>
+                  <a:txBody>
+                    <a:bodyPr wrap="square"/>
+                    <a:lstStyle/>
+                    <a:p>
+                      <a:r>
+                        <a:rPr sz="1000">
+                          <a:solidFill>
+                            <a:srgbClr val="262B2F"/>
+                          </a:solidFill>
+                          <a:latin typeface="Arial"/>
+                        </a:rPr>
+                        <a:t>375.3</a:t>
+                      </a:r>
+                    </a:p>
+                  </a:txBody>
+                  <a:tcPr anchor="ctr" marT="12700" marB="12700" marL="63500" marR="63500">
+                    <a:solidFill>
+                      <a:srgbClr val="FFFFFF"/>
+                    </a:solidFill>
+                  </a:tcPr>
+                </a:tc>
+                <a:tc>
+                  <a:txBody>
+                    <a:bodyPr wrap="square"/>
+                    <a:lstStyle/>
+                    <a:p>
+                      <a:r>
+                        <a:rPr sz="1000">
+                          <a:solidFill>
+                            <a:srgbClr val="262B2F"/>
+                          </a:solidFill>
+                          <a:latin typeface="Arial"/>
+                        </a:rPr>
+                        <a:t>15.4×</a:t>
+                      </a:r>
+                    </a:p>
+                  </a:txBody>
+                  <a:tcPr anchor="ctr" marT="12700" marB="12700" marL="63500" marR="63500">
+                    <a:solidFill>
+                      <a:srgbClr val="FFFFFF"/>
+                    </a:solidFill>
+                  </a:tcPr>
+                </a:tc>
+                <a:tc>
+                  <a:txBody>
+                    <a:bodyPr wrap="square"/>
+                    <a:lstStyle/>
+                    <a:p>
+                      <a:r>
+                        <a:rPr sz="1000">
+                          <a:solidFill>
+                            <a:srgbClr val="262B2F"/>
+                          </a:solidFill>
+                          <a:latin typeface="Arial"/>
+                        </a:rPr>
+                        <a:t>17.0 GB</a:t>
+                      </a:r>
+                    </a:p>
+                  </a:txBody>
+                  <a:tcPr anchor="ctr" marT="12700" marB="12700" marL="63500" marR="63500">
+                    <a:solidFill>
+                      <a:srgbClr val="FFFFFF"/>
+                    </a:solidFill>
+                  </a:tcPr>
+                </a:tc>
+              </a:tr>
+              <a:tr h="205740">
+                <a:tc>
+                  <a:txBody>
+                    <a:bodyPr wrap="square"/>
+                    <a:lstStyle/>
+                    <a:p>
+                      <a:r>
+                        <a:rPr sz="1000">
+                          <a:solidFill>
+                            <a:srgbClr val="262B2F"/>
+                          </a:solidFill>
+                          <a:latin typeface="Arial"/>
+                        </a:rPr>
+                        <a:t>corr=0.90, k=None</a:t>
+                      </a:r>
+                    </a:p>
+                  </a:txBody>
+                  <a:tcPr anchor="ctr" marT="12700" marB="12700" marL="63500" marR="63500">
+                    <a:solidFill>
+                      <a:srgbClr val="FFFFFF"/>
+                    </a:solidFill>
+                  </a:tcPr>
+                </a:tc>
+                <a:tc>
+                  <a:txBody>
+                    <a:bodyPr wrap="square"/>
+                    <a:lstStyle/>
+                    <a:p>
+                      <a:r>
+                        <a:rPr sz="1000">
+                          <a:solidFill>
+                            <a:srgbClr val="262B2F"/>
+                          </a:solidFill>
+                          <a:latin typeface="Arial"/>
+                        </a:rPr>
+                        <a:t>6315.9</a:t>
+                      </a:r>
+                    </a:p>
+                  </a:txBody>
+                  <a:tcPr anchor="ctr" marT="12700" marB="12700" marL="63500" marR="63500">
+                    <a:solidFill>
+                      <a:srgbClr val="FFFFFF"/>
+                    </a:solidFill>
+                  </a:tcPr>
+                </a:tc>
+                <a:tc>
+                  <a:txBody>
+                    <a:bodyPr wrap="square"/>
+                    <a:lstStyle/>
+                    <a:p>
+                      <a:r>
+                        <a:rPr sz="1000">
+                          <a:solidFill>
+                            <a:srgbClr val="262B2F"/>
+                          </a:solidFill>
+                          <a:latin typeface="Arial"/>
+                        </a:rPr>
+                        <a:t>359.0</a:t>
+                      </a:r>
+                    </a:p>
+                  </a:txBody>
+                  <a:tcPr anchor="ctr" marT="12700" marB="12700" marL="63500" marR="63500">
+                    <a:solidFill>
+                      <a:srgbClr val="FFFFFF"/>
+                    </a:solidFill>
+                  </a:tcPr>
+                </a:tc>
+                <a:tc>
+                  <a:txBody>
+                    <a:bodyPr wrap="square"/>
+                    <a:lstStyle/>
+                    <a:p>
+                      <a:r>
+                        <a:rPr sz="1000">
+                          <a:solidFill>
+                            <a:srgbClr val="262B2F"/>
+                          </a:solidFill>
+                          <a:latin typeface="Arial"/>
+                        </a:rPr>
+                        <a:t>17.6×</a:t>
+                      </a:r>
+                    </a:p>
+                  </a:txBody>
+                  <a:tcPr anchor="ctr" marT="12700" marB="12700" marL="63500" marR="63500">
+                    <a:solidFill>
+                      <a:srgbClr val="FFFFFF"/>
+                    </a:solidFill>
+                  </a:tcPr>
+                </a:tc>
+                <a:tc>
+                  <a:txBody>
+                    <a:bodyPr wrap="square"/>
+                    <a:lstStyle/>
+                    <a:p>
+                      <a:r>
+                        <a:rPr sz="1000">
+                          <a:solidFill>
+                            <a:srgbClr val="262B2F"/>
+                          </a:solidFill>
+                          <a:latin typeface="Arial"/>
+                        </a:rPr>
+                        <a:t>17.4 GB</a:t>
+                      </a:r>
+                    </a:p>
+                  </a:txBody>
+                  <a:tcPr anchor="ctr" marT="12700" marB="12700" marL="63500" marR="63500">
+                    <a:solidFill>
+                      <a:srgbClr val="FFFFFF"/>
+                    </a:solidFill>
+                  </a:tcPr>
+                </a:tc>
+              </a:tr>
+              <a:tr h="205740">
+                <a:tc>
+                  <a:txBody>
+                    <a:bodyPr wrap="square"/>
+                    <a:lstStyle/>
+                    <a:p>
+                      <a:r>
+                        <a:rPr sz="1000">
+                          <a:solidFill>
+                            <a:srgbClr val="262B2F"/>
+                          </a:solidFill>
+                          <a:latin typeface="Arial"/>
+                        </a:rPr>
+                        <a:t>corr=None, k=30</a:t>
+                      </a:r>
+                    </a:p>
+                  </a:txBody>
+                  <a:tcPr anchor="ctr" marT="12700" marB="12700" marL="63500" marR="63500">
+                    <a:solidFill>
+                      <a:srgbClr val="FFFFFF"/>
+                    </a:solidFill>
+                  </a:tcPr>
+                </a:tc>
+                <a:tc>
+                  <a:txBody>
+                    <a:bodyPr wrap="square"/>
+                    <a:lstStyle/>
+                    <a:p>
+                      <a:r>
+                        <a:rPr sz="1000">
+                          <a:solidFill>
+                            <a:srgbClr val="262B2F"/>
+                          </a:solidFill>
+                          <a:latin typeface="Arial"/>
+                        </a:rPr>
+                        <a:t>4567.2</a:t>
+                      </a:r>
+                    </a:p>
+                  </a:txBody>
+                  <a:tcPr anchor="ctr" marT="12700" marB="12700" marL="63500" marR="63500">
+                    <a:solidFill>
+                      <a:srgbClr val="FFFFFF"/>
+                    </a:solidFill>
+                  </a:tcPr>
+                </a:tc>
+                <a:tc>
+                  <a:txBody>
+                    <a:bodyPr wrap="square"/>
+                    <a:lstStyle/>
+                    <a:p>
+                      <a:r>
+                        <a:rPr sz="1000">
+                          <a:solidFill>
+                            <a:srgbClr val="262B2F"/>
+                          </a:solidFill>
+                          <a:latin typeface="Arial"/>
+                        </a:rPr>
+                        <a:t>415.6</a:t>
+                      </a:r>
+                    </a:p>
+                  </a:txBody>
+                  <a:tcPr anchor="ctr" marT="12700" marB="12700" marL="63500" marR="63500">
+                    <a:solidFill>
+                      <a:srgbClr val="FFFFFF"/>
+                    </a:solidFill>
+                  </a:tcPr>
+                </a:tc>
+                <a:tc>
+                  <a:txBody>
+                    <a:bodyPr wrap="square"/>
+                    <a:lstStyle/>
+                    <a:p>
+                      <a:r>
+                        <a:rPr sz="1000">
+                          <a:solidFill>
+                            <a:srgbClr val="262B2F"/>
+                          </a:solidFill>
+                          <a:latin typeface="Arial"/>
+                        </a:rPr>
+                        <a:t>11.0×</a:t>
+                      </a:r>
+                    </a:p>
+                  </a:txBody>
+                  <a:tcPr anchor="ctr" marT="12700" marB="12700" marL="63500" marR="63500">
+                    <a:solidFill>
+                      <a:srgbClr val="FFFFFF"/>
+                    </a:solidFill>
+                  </a:tcPr>
+                </a:tc>
+                <a:tc>
+                  <a:txBody>
+                    <a:bodyPr wrap="square"/>
+                    <a:lstStyle/>
+                    <a:p>
+                      <a:r>
+                        <a:rPr sz="1000">
+                          <a:solidFill>
+                            <a:srgbClr val="262B2F"/>
+                          </a:solidFill>
+                          <a:latin typeface="Arial"/>
+                        </a:rPr>
+                        <a:t>20.4 GB</a:t>
+                      </a:r>
+                    </a:p>
+                  </a:txBody>
+                  <a:tcPr anchor="ctr" marT="12700" marB="12700" marL="63500" marR="63500">
+                    <a:solidFill>
+                      <a:srgbClr val="FFFFFF"/>
+                    </a:solidFill>
+                  </a:tcPr>
+                </a:tc>
+              </a:tr>
+              <a:tr h="205740">
+                <a:tc>
+                  <a:txBody>
+                    <a:bodyPr wrap="square"/>
+                    <a:lstStyle/>
+                    <a:p>
+                      <a:r>
+                        <a:rPr sz="1000">
+                          <a:solidFill>
+                            <a:srgbClr val="262B2F"/>
+                          </a:solidFill>
+                          <a:latin typeface="Arial"/>
+                        </a:rPr>
+                        <a:t>corr=None, k=50</a:t>
+                      </a:r>
+                    </a:p>
+                  </a:txBody>
+                  <a:tcPr anchor="ctr" marT="12700" marB="12700" marL="63500" marR="63500">
+                    <a:solidFill>
+                      <a:srgbClr val="FFFFFF"/>
+                    </a:solidFill>
+                  </a:tcPr>
+                </a:tc>
+                <a:tc>
+                  <a:txBody>
+                    <a:bodyPr wrap="square"/>
+                    <a:lstStyle/>
+                    <a:p>
+                      <a:r>
+                        <a:rPr sz="1000">
+                          <a:solidFill>
+                            <a:srgbClr val="262B2F"/>
+                          </a:solidFill>
+                          <a:latin typeface="Arial"/>
+                        </a:rPr>
+                        <a:t>5602.4</a:t>
+                      </a:r>
+                    </a:p>
+                  </a:txBody>
+                  <a:tcPr anchor="ctr" marT="12700" marB="12700" marL="63500" marR="63500">
+                    <a:solidFill>
+                      <a:srgbClr val="FFFFFF"/>
+                    </a:solidFill>
+                  </a:tcPr>
+                </a:tc>
+                <a:tc>
+                  <a:txBody>
+                    <a:bodyPr wrap="square"/>
+                    <a:lstStyle/>
+                    <a:p>
+                      <a:r>
+                        <a:rPr sz="1000">
+                          <a:solidFill>
+                            <a:srgbClr val="262B2F"/>
+                          </a:solidFill>
+                          <a:latin typeface="Arial"/>
+                        </a:rPr>
+                        <a:t>356.7</a:t>
+                      </a:r>
+                    </a:p>
+                  </a:txBody>
+                  <a:tcPr anchor="ctr" marT="12700" marB="12700" marL="63500" marR="63500">
+                    <a:solidFill>
+                      <a:srgbClr val="FFFFFF"/>
+                    </a:solidFill>
+                  </a:tcPr>
+                </a:tc>
+                <a:tc>
+                  <a:txBody>
+                    <a:bodyPr wrap="square"/>
+                    <a:lstStyle/>
+                    <a:p>
+                      <a:r>
+                        <a:rPr sz="1000">
+                          <a:solidFill>
+                            <a:srgbClr val="262B2F"/>
+                          </a:solidFill>
+                          <a:latin typeface="Arial"/>
+                        </a:rPr>
+                        <a:t>15.7×</a:t>
+                      </a:r>
+                    </a:p>
+                  </a:txBody>
+                  <a:tcPr anchor="ctr" marT="12700" marB="12700" marL="63500" marR="63500">
+                    <a:solidFill>
+                      <a:srgbClr val="FFFFFF"/>
+                    </a:solidFill>
+                  </a:tcPr>
+                </a:tc>
+                <a:tc>
+                  <a:txBody>
+                    <a:bodyPr wrap="square"/>
+                    <a:lstStyle/>
+                    <a:p>
+                      <a:r>
+                        <a:rPr sz="1000">
+                          <a:solidFill>
+                            <a:srgbClr val="262B2F"/>
+                          </a:solidFill>
+                          <a:latin typeface="Arial"/>
+                        </a:rPr>
+                        <a:t>17.5 GB</a:t>
+                      </a:r>
+                    </a:p>
+                  </a:txBody>
+                  <a:tcPr anchor="ctr" marT="12700" marB="12700" marL="63500" marR="63500">
+                    <a:solidFill>
+                      <a:srgbClr val="FFFFFF"/>
+                    </a:solidFill>
+                  </a:tcPr>
+                </a:tc>
+              </a:tr>
+              <a:tr h="205740">
+                <a:tc>
+                  <a:txBody>
+                    <a:bodyPr wrap="square"/>
+                    <a:lstStyle/>
+                    <a:p>
+                      <a:r>
+                        <a:rPr sz="1000" b="1">
+                          <a:solidFill>
+                            <a:srgbClr val="262B2F"/>
+                          </a:solidFill>
+                          <a:latin typeface="Arial"/>
+                        </a:rPr>
+                        <a:t>corr=None, k=None</a:t>
+                      </a:r>
+                    </a:p>
+                  </a:txBody>
+                  <a:tcPr anchor="ctr" marT="12700" marB="12700" marL="63500" marR="63500">
+                    <a:solidFill>
+                      <a:srgbClr val="FFE3C1"/>
+                    </a:solidFill>
+                  </a:tcPr>
+                </a:tc>
+                <a:tc>
+                  <a:txBody>
+                    <a:bodyPr wrap="square"/>
+                    <a:lstStyle/>
+                    <a:p>
+                      <a:r>
+                        <a:rPr sz="1000" b="1">
+                          <a:solidFill>
+                            <a:srgbClr val="262B2F"/>
+                          </a:solidFill>
+                          <a:latin typeface="Arial"/>
+                        </a:rPr>
+                        <a:t>7962.4</a:t>
+                      </a:r>
+                    </a:p>
+                  </a:txBody>
+                  <a:tcPr anchor="ctr" marT="12700" marB="12700" marL="63500" marR="63500">
+                    <a:solidFill>
+                      <a:srgbClr val="FFE3C1"/>
+                    </a:solidFill>
+                  </a:tcPr>
+                </a:tc>
+                <a:tc>
+                  <a:txBody>
+                    <a:bodyPr wrap="square"/>
+                    <a:lstStyle/>
+                    <a:p>
+                      <a:r>
+                        <a:rPr sz="1000" b="1">
+                          <a:solidFill>
+                            <a:srgbClr val="262B2F"/>
+                          </a:solidFill>
+                          <a:latin typeface="Arial"/>
+                        </a:rPr>
+                        <a:t>339.4</a:t>
+                      </a:r>
+                    </a:p>
+                  </a:txBody>
+                  <a:tcPr anchor="ctr" marT="12700" marB="12700" marL="63500" marR="63500">
+                    <a:solidFill>
+                      <a:srgbClr val="FFE3C1"/>
+                    </a:solidFill>
+                  </a:tcPr>
+                </a:tc>
+                <a:tc>
+                  <a:txBody>
+                    <a:bodyPr wrap="square"/>
+                    <a:lstStyle/>
+                    <a:p>
+                      <a:r>
+                        <a:rPr sz="1000" b="1">
+                          <a:solidFill>
+                            <a:srgbClr val="262B2F"/>
+                          </a:solidFill>
+                          <a:latin typeface="Arial"/>
+                        </a:rPr>
+                        <a:t>23.5×</a:t>
+                      </a:r>
+                    </a:p>
+                  </a:txBody>
+                  <a:tcPr anchor="ctr" marT="12700" marB="12700" marL="63500" marR="63500">
+                    <a:solidFill>
+                      <a:srgbClr val="FFE3C1"/>
+                    </a:solidFill>
+                  </a:tcPr>
+                </a:tc>
+                <a:tc>
+                  <a:txBody>
+                    <a:bodyPr wrap="square"/>
+                    <a:lstStyle/>
+                    <a:p>
+                      <a:r>
+                        <a:rPr sz="1000" b="1">
+                          <a:solidFill>
+                            <a:srgbClr val="262B2F"/>
+                          </a:solidFill>
+                          <a:latin typeface="Arial"/>
+                        </a:rPr>
+                        <a:t>16.3 GB</a:t>
+                      </a:r>
+                    </a:p>
+                  </a:txBody>
+                  <a:tcPr anchor="ctr" marT="12700" marB="12700" marL="63500" marR="63500">
+                    <a:solidFill>
+                      <a:srgbClr val="FFE3C1"/>
+                    </a:solidFill>
+                  </a:tcPr>
+                </a:tc>
+              </a:tr>
+            </a:tbl>
+          </a:graphicData>
+        </a:graphic>
+      </p:graphicFrame>
+    </p:spTree>
+  </p:cSld>
+  <p:clrMapOvr>
+    <a:masterClrMapping/>
+  </p:clrMapOvr>
+</p:sld>
+</file>
+
+<file path=ppt/slides/slide13.xml><?xml version="1.0" encoding="utf-8"?>
+<p:sld xmlns:a="http://schemas.openxmlformats.org/drawingml/2006/main" xmlns:p="http://schemas.openxmlformats.org/presentationml/2006/main" xmlns:r="http://schemas.openxmlformats.org/officeDocument/2006/relationships">
+  <p:cSld>
+    <p:spTree>
+      <p:nvGrpSpPr>
+        <p:cNvPr id="1" name=""/>
+        <p:cNvGrpSpPr/>
+        <p:nvPr/>
+      </p:nvGrpSpPr>
+      <p:grpSpPr/>
+      <p:sp>
+        <p:nvSpPr>
+          <p:cNvPr id="2" name="Title 1"/>
+          <p:cNvSpPr>
+            <a:spLocks noGrp="1"/>
+          </p:cNvSpPr>
+          <p:nvPr>
+            <p:ph type="title"/>
+          </p:nvPr>
+        </p:nvSpPr>
+        <p:spPr/>
+        <p:txBody>
+          <a:bodyPr/>
+          <a:lstStyle/>
+          <a:p>
+            <a:r>
+              <a:t>Backup — Cache Viability Ranking (η, 15 models)</a:t>
+            </a:r>
+          </a:p>
+        </p:txBody>
+      </p:sp>
+      <p:pic>
+        <p:nvPicPr>
+          <p:cNvPr id="3" name="Picture 2" descr="viability_rank.png"/>
+          <p:cNvPicPr>
+            <a:picLocks noChangeAspect="1"/>
+          </p:cNvPicPr>
+          <p:nvPr/>
+        </p:nvPicPr>
+        <p:blipFill>
+          <a:blip r:embed="rId2"/>
+          <a:stretch>
+            <a:fillRect/>
+          </a:stretch>
+        </p:blipFill>
+        <p:spPr>
+          <a:xfrm>
+            <a:off x="2605850" y="1554480"/>
+            <a:ext cx="6949819" cy="4114800"/>
+          </a:xfrm>
+          <a:prstGeom prst="rect">
+            <a:avLst/>
+          </a:prstGeom>
+        </p:spPr>
+      </p:pic>
+      <p:sp>
+        <p:nvSpPr>
+          <p:cNvPr id="4" name="TextBox 3"/>
+          <p:cNvSpPr txBox="1"/>
+          <p:nvPr/>
+        </p:nvSpPr>
+        <p:spPr>
+          <a:xfrm>
+            <a:off x="1280160" y="5760720"/>
+            <a:ext cx="9601200" cy="365760"/>
+          </a:xfrm>
+          <a:prstGeom prst="rect">
+            <a:avLst/>
+          </a:prstGeom>
+          <a:noFill/>
+        </p:spPr>
+        <p:txBody>
+          <a:bodyPr wrap="square">
+            <a:spAutoFit/>
+          </a:bodyPr>
+          <a:lstStyle/>
+          <a:p>
+            <a:pPr algn="ctr"/>
+            <a:r>
+              <a:rPr sz="1200" i="1">
+                <a:solidFill>
+                  <a:srgbClr val="768692"/>
+                </a:solidFill>
+              </a:rPr>
+              <a:t>η = seconds of compute saved per MB stored. Blue viable (η &gt; 2), orange not viable (η &lt; 0.5).</a:t>
+            </a:r>
+          </a:p>
+        </p:txBody>
+      </p:sp>
+    </p:spTree>
+  </p:cSld>
+  <p:clrMapOvr>
+    <a:masterClrMapping/>
+  </p:clrMapOvr>
+</p:sld>
+</file>
+
+<file path=ppt/slides/slide14.xml><?xml version="1.0" encoding="utf-8"?>
+<p:sld xmlns:a="http://schemas.openxmlformats.org/drawingml/2006/main" xmlns:p="http://schemas.openxmlformats.org/presentationml/2006/main" xmlns:r="http://schemas.openxmlformats.org/officeDocument/2006/relationships">
+  <p:cSld>
+    <p:spTree>
+      <p:nvGrpSpPr>
+        <p:cNvPr id="1" name=""/>
+        <p:cNvGrpSpPr/>
+        <p:nvPr/>
+      </p:nvGrpSpPr>
+      <p:grpSpPr/>
+      <p:sp>
+        <p:nvSpPr>
+          <p:cNvPr id="2" name="Title 1"/>
+          <p:cNvSpPr>
+            <a:spLocks noGrp="1"/>
+          </p:cNvSpPr>
+          <p:nvPr>
+            <p:ph type="title"/>
+          </p:nvPr>
+        </p:nvSpPr>
+        <p:spPr/>
+        <p:txBody>
+          <a:bodyPr/>
+          <a:lstStyle/>
+          <a:p>
+            <a:r>
+              <a:t>Backup — Confusion Matrix (best XGBoost)</a:t>
+            </a:r>
+          </a:p>
+        </p:txBody>
+      </p:sp>
+      <p:pic>
+        <p:nvPicPr>
+          <p:cNvPr id="3" name="Picture 2" descr="confusion.png"/>
+          <p:cNvPicPr>
+            <a:picLocks noChangeAspect="1"/>
+          </p:cNvPicPr>
+          <p:nvPr/>
+        </p:nvPicPr>
+        <p:blipFill>
+          <a:blip r:embed="rId2"/>
+          <a:stretch>
+            <a:fillRect/>
+          </a:stretch>
+        </p:blipFill>
+        <p:spPr>
+          <a:xfrm>
+            <a:off x="1645196" y="1554480"/>
+            <a:ext cx="8871127" cy="4114800"/>
+          </a:xfrm>
+          <a:prstGeom prst="rect">
+            <a:avLst/>
+          </a:prstGeom>
+        </p:spPr>
+      </p:pic>
+      <p:sp>
+        <p:nvSpPr>
+          <p:cNvPr id="4" name="TextBox 3"/>
+          <p:cNvSpPr txBox="1"/>
+          <p:nvPr/>
+        </p:nvSpPr>
+        <p:spPr>
+          <a:xfrm>
+            <a:off x="1280160" y="5760720"/>
+            <a:ext cx="9601200" cy="365760"/>
+          </a:xfrm>
+          <a:prstGeom prst="rect">
+            <a:avLst/>
+          </a:prstGeom>
+          <a:noFill/>
+        </p:spPr>
+        <p:txBody>
+          <a:bodyPr wrap="square">
+            <a:spAutoFit/>
+          </a:bodyPr>
+          <a:lstStyle/>
+          <a:p>
+            <a:pPr algn="ctr"/>
+            <a:r>
+              <a:rPr sz="1200" i="1">
+                <a:solidFill>
+                  <a:srgbClr val="768692"/>
+                </a:solidFill>
+              </a:rPr>
+              <a:t>Aggregated 5×5 confusion across all 128 LOSO folds; right panel row-normalised (recall).</a:t>
+            </a:r>
+          </a:p>
+        </p:txBody>
+      </p:sp>
+    </p:spTree>
+  </p:cSld>
+  <p:clrMapOvr>
+    <a:masterClrMapping/>
+  </p:clrMapOvr>
+</p:sld>
+</file>
+
+<file path=ppt/slides/slide15.xml><?xml version="1.0" encoding="utf-8"?>
+<p:sld xmlns:a="http://schemas.openxmlformats.org/drawingml/2006/main" xmlns:p="http://schemas.openxmlformats.org/presentationml/2006/main" xmlns:r="http://schemas.openxmlformats.org/officeDocument/2006/relationships">
+  <p:cSld>
+    <p:spTree>
+      <p:nvGrpSpPr>
+        <p:cNvPr id="1" name=""/>
+        <p:cNvGrpSpPr/>
+        <p:nvPr/>
+      </p:nvGrpSpPr>
+      <p:grpSpPr/>
+      <p:sp>
+        <p:nvSpPr>
+          <p:cNvPr id="2" name="Title 1"/>
+          <p:cNvSpPr>
+            <a:spLocks noGrp="1"/>
+          </p:cNvSpPr>
+          <p:nvPr>
+            <p:ph type="title"/>
+          </p:nvPr>
+        </p:nvSpPr>
+        <p:spPr/>
+        <p:txBody>
+          <a:bodyPr/>
+          <a:lstStyle/>
+          <a:p>
+            <a:r>
+              <a:t>Backup — Global vs. Per-Fold Feature Selection</a:t>
+            </a:r>
+          </a:p>
+        </p:txBody>
+      </p:sp>
+      <p:graphicFrame>
+        <p:nvGraphicFramePr>
+          <p:cNvPr id="3" name="Table 2"/>
+          <p:cNvGraphicFramePr>
+            <a:graphicFrameLocks noGrp="1"/>
+          </p:cNvGraphicFramePr>
+          <p:nvPr/>
+        </p:nvGraphicFramePr>
+        <p:xfrm>
+          <a:off x="822960" y="1737360"/>
+          <a:ext cx="10515600" cy="3657600"/>
+        </p:xfrm>
+        <a:graphic>
+          <a:graphicData uri="http://schemas.openxmlformats.org/drawingml/2006/table">
+            <a:tbl>
+              <a:tblPr firstRow="1" bandRow="1">
+                <a:tableStyleId>{5C22544A-7EE6-4342-B048-85BDC9FD1C3A}</a:tableStyleId>
+              </a:tblPr>
+              <a:tblGrid>
+                <a:gridCol w="3657600"/>
+                <a:gridCol w="3429000"/>
+                <a:gridCol w="3429000"/>
+              </a:tblGrid>
+              <a:tr h="457200">
+                <a:tc>
+                  <a:txBody>
+                    <a:bodyPr wrap="square"/>
+                    <a:lstStyle/>
+                    <a:p>
+                      <a:r>
+                        <a:rPr sz="1500" b="1">
+                          <a:solidFill>
+                            <a:srgbClr val="FFFFFF"/>
+                          </a:solidFill>
+                          <a:latin typeface="Arial"/>
+                        </a:rPr>
+                        <a:t>Aspect</a:t>
+                      </a:r>
+                    </a:p>
+                  </a:txBody>
+                  <a:tcPr anchor="ctr" marT="12700" marB="12700" marL="63500" marR="63500">
+                    <a:solidFill>
+                      <a:srgbClr val="FF9E1B"/>
+                    </a:solidFill>
+                  </a:tcPr>
+                </a:tc>
+                <a:tc>
+                  <a:txBody>
+                    <a:bodyPr wrap="square"/>
+                    <a:lstStyle/>
+                    <a:p>
+                      <a:r>
+                        <a:rPr sz="1500" b="1">
+                          <a:solidFill>
+                            <a:srgbClr val="FFFFFF"/>
+                          </a:solidFill>
+                          <a:latin typeface="Arial"/>
+                        </a:rPr>
+                        <a:t>Global (chosen)</a:t>
+                      </a:r>
+                    </a:p>
+                  </a:txBody>
+                  <a:tcPr anchor="ctr" marT="12700" marB="12700" marL="63500" marR="63500">
+                    <a:solidFill>
+                      <a:srgbClr val="FF9E1B"/>
+                    </a:solidFill>
+                  </a:tcPr>
+                </a:tc>
+                <a:tc>
+                  <a:txBody>
+                    <a:bodyPr wrap="square"/>
+                    <a:lstStyle/>
+                    <a:p>
+                      <a:r>
+                        <a:rPr sz="1500" b="1">
+                          <a:solidFill>
+                            <a:srgbClr val="FFFFFF"/>
+                          </a:solidFill>
+                          <a:latin typeface="Arial"/>
+                        </a:rPr>
+                        <a:t>Per-Fold</a:t>
+                      </a:r>
+                    </a:p>
+                  </a:txBody>
+                  <a:tcPr anchor="ctr" marT="12700" marB="12700" marL="63500" marR="63500">
+                    <a:solidFill>
+                      <a:srgbClr val="FF9E1B"/>
+                    </a:solidFill>
+                  </a:tcPr>
+                </a:tc>
+              </a:tr>
+              <a:tr h="457200">
+                <a:tc>
+                  <a:txBody>
+                    <a:bodyPr wrap="square"/>
+                    <a:lstStyle/>
+                    <a:p>
+                      <a:r>
+                        <a:rPr sz="1500">
+                          <a:solidFill>
+                            <a:srgbClr val="262B2F"/>
+                          </a:solidFill>
+                          <a:latin typeface="Arial"/>
+                        </a:rPr>
+                        <a:t>Selection fitted on</a:t>
+                      </a:r>
+                    </a:p>
+                  </a:txBody>
+                  <a:tcPr anchor="ctr" marT="12700" marB="12700" marL="63500" marR="63500">
+                    <a:solidFill>
+                      <a:srgbClr val="FFFFFF"/>
+                    </a:solidFill>
+                  </a:tcPr>
+                </a:tc>
+                <a:tc>
+                  <a:txBody>
+                    <a:bodyPr wrap="square"/>
+                    <a:lstStyle/>
+                    <a:p>
+                      <a:r>
+                        <a:rPr sz="1500">
+                          <a:solidFill>
+                            <a:srgbClr val="262B2F"/>
+                          </a:solidFill>
+                          <a:latin typeface="Arial"/>
+                        </a:rPr>
+                        <a:t>All subjects (once)</a:t>
+                      </a:r>
+                    </a:p>
+                  </a:txBody>
+                  <a:tcPr anchor="ctr" marT="12700" marB="12700" marL="63500" marR="63500">
+                    <a:solidFill>
+                      <a:srgbClr val="FFFFFF"/>
+                    </a:solidFill>
+                  </a:tcPr>
+                </a:tc>
+                <a:tc>
+                  <a:txBody>
+                    <a:bodyPr wrap="square"/>
+                    <a:lstStyle/>
+                    <a:p>
+                      <a:r>
+                        <a:rPr sz="1500">
+                          <a:solidFill>
+                            <a:srgbClr val="262B2F"/>
+                          </a:solidFill>
+                          <a:latin typeface="Arial"/>
+                        </a:rPr>
+                        <a:t>Training fold only</a:t>
+                      </a:r>
+                    </a:p>
+                  </a:txBody>
+                  <a:tcPr anchor="ctr" marT="12700" marB="12700" marL="63500" marR="63500">
+                    <a:solidFill>
+                      <a:srgbClr val="FFFFFF"/>
+                    </a:solidFill>
+                  </a:tcPr>
+                </a:tc>
+              </a:tr>
+              <a:tr h="457200">
+                <a:tc>
+                  <a:txBody>
+                    <a:bodyPr wrap="square"/>
+                    <a:lstStyle/>
+                    <a:p>
+                      <a:r>
+                        <a:rPr sz="1500">
+                          <a:solidFill>
+                            <a:srgbClr val="262B2F"/>
+                          </a:solidFill>
+                          <a:latin typeface="Arial"/>
+                        </a:rPr>
+                        <a:t>Label leakage</a:t>
+                      </a:r>
+                    </a:p>
+                  </a:txBody>
+                  <a:tcPr anchor="ctr" marT="12700" marB="12700" marL="63500" marR="63500">
+                    <a:solidFill>
+                      <a:srgbClr val="FFFFFF"/>
+                    </a:solidFill>
+                  </a:tcPr>
+                </a:tc>
+                <a:tc>
+                  <a:txBody>
+                    <a:bodyPr wrap="square"/>
+                    <a:lstStyle/>
+                    <a:p>
+                      <a:r>
+                        <a:rPr sz="1500">
+                          <a:solidFill>
+                            <a:srgbClr val="262B2F"/>
+                          </a:solidFill>
+                          <a:latin typeface="Arial"/>
+                        </a:rPr>
+                        <a:t>1/128 ≈ 0.8%</a:t>
+                      </a:r>
+                    </a:p>
+                  </a:txBody>
+                  <a:tcPr anchor="ctr" marT="12700" marB="12700" marL="63500" marR="63500">
+                    <a:solidFill>
+                      <a:srgbClr val="FFFFFF"/>
+                    </a:solidFill>
+                  </a:tcPr>
+                </a:tc>
+                <a:tc>
+                  <a:txBody>
+                    <a:bodyPr wrap="square"/>
+                    <a:lstStyle/>
+                    <a:p>
+                      <a:r>
+                        <a:rPr sz="1500">
+                          <a:solidFill>
+                            <a:srgbClr val="262B2F"/>
+                          </a:solidFill>
+                          <a:latin typeface="Arial"/>
+                        </a:rPr>
+                        <a:t>None</a:t>
+                      </a:r>
+                    </a:p>
+                  </a:txBody>
+                  <a:tcPr anchor="ctr" marT="12700" marB="12700" marL="63500" marR="63500">
+                    <a:solidFill>
+                      <a:srgbClr val="FFFFFF"/>
+                    </a:solidFill>
+                  </a:tcPr>
+                </a:tc>
+              </a:tr>
+              <a:tr h="457200">
+                <a:tc>
+                  <a:txBody>
+                    <a:bodyPr wrap="square"/>
+                    <a:lstStyle/>
+                    <a:p>
+                      <a:r>
+                        <a:rPr sz="1500" b="1">
+                          <a:solidFill>
+                            <a:srgbClr val="262B2F"/>
+                          </a:solidFill>
+                          <a:latin typeface="Arial"/>
+                        </a:rPr>
+                        <a:t>Accuracy difference</a:t>
+                      </a:r>
+                    </a:p>
+                  </a:txBody>
+                  <a:tcPr anchor="ctr" marT="12700" marB="12700" marL="63500" marR="63500">
+                    <a:solidFill>
+                      <a:srgbClr val="FFE3C1"/>
+                    </a:solidFill>
+                  </a:tcPr>
+                </a:tc>
+                <a:tc>
+                  <a:txBody>
+                    <a:bodyPr wrap="square"/>
+                    <a:lstStyle/>
+                    <a:p>
+                      <a:r>
+                        <a:rPr sz="1500" b="1">
+                          <a:solidFill>
+                            <a:srgbClr val="262B2F"/>
+                          </a:solidFill>
+                          <a:latin typeface="Arial"/>
+                        </a:rPr>
+                        <a:t>±0.4% mean, ≤1.1% max</a:t>
+                      </a:r>
+                    </a:p>
+                  </a:txBody>
+                  <a:tcPr anchor="ctr" marT="12700" marB="12700" marL="63500" marR="63500">
+                    <a:solidFill>
+                      <a:srgbClr val="FFE3C1"/>
+                    </a:solidFill>
+                  </a:tcPr>
+                </a:tc>
+                <a:tc>
+                  <a:txBody>
+                    <a:bodyPr wrap="square"/>
+                    <a:lstStyle/>
+                    <a:p>
+                      <a:r>
+                        <a:rPr sz="1500" b="1">
+                          <a:solidFill>
+                            <a:srgbClr val="262B2F"/>
+                          </a:solidFill>
+                          <a:latin typeface="Arial"/>
+                        </a:rPr>
+                        <a:t>Baseline</a:t>
+                      </a:r>
+                    </a:p>
+                  </a:txBody>
+                  <a:tcPr anchor="ctr" marT="12700" marB="12700" marL="63500" marR="63500">
+                    <a:solidFill>
+                      <a:srgbClr val="FFE3C1"/>
+                    </a:solidFill>
+                  </a:tcPr>
+                </a:tc>
+              </a:tr>
+              <a:tr h="457200">
+                <a:tc>
+                  <a:txBody>
+                    <a:bodyPr wrap="square"/>
+                    <a:lstStyle/>
+                    <a:p>
+                      <a:r>
+                        <a:rPr sz="1500">
+                          <a:solidFill>
+                            <a:srgbClr val="262B2F"/>
+                          </a:solidFill>
+                          <a:latin typeface="Arial"/>
+                        </a:rPr>
+                        <a:t>XGBoost warm speedup</a:t>
+                      </a:r>
+                    </a:p>
+                  </a:txBody>
+                  <a:tcPr anchor="ctr" marT="12700" marB="12700" marL="63500" marR="63500">
+                    <a:solidFill>
+                      <a:srgbClr val="FFFFFF"/>
+                    </a:solidFill>
+                  </a:tcPr>
+                </a:tc>
+                <a:tc>
+                  <a:txBody>
+                    <a:bodyPr wrap="square"/>
+                    <a:lstStyle/>
+                    <a:p>
+                      <a:r>
+                        <a:rPr sz="1500">
+                          <a:solidFill>
+                            <a:srgbClr val="262B2F"/>
+                          </a:solidFill>
+                          <a:latin typeface="Arial"/>
+                        </a:rPr>
+                        <a:t>14–23×</a:t>
+                      </a:r>
+                    </a:p>
+                  </a:txBody>
+                  <a:tcPr anchor="ctr" marT="12700" marB="12700" marL="63500" marR="63500">
+                    <a:solidFill>
+                      <a:srgbClr val="FFFFFF"/>
+                    </a:solidFill>
+                  </a:tcPr>
+                </a:tc>
+                <a:tc>
+                  <a:txBody>
+                    <a:bodyPr wrap="square"/>
+                    <a:lstStyle/>
+                    <a:p>
+                      <a:r>
+                        <a:rPr sz="1500">
+                          <a:solidFill>
+                            <a:srgbClr val="262B2F"/>
+                          </a:solidFill>
+                          <a:latin typeface="Arial"/>
+                        </a:rPr>
+                        <a:t>4–9×</a:t>
+                      </a:r>
+                    </a:p>
+                  </a:txBody>
+                  <a:tcPr anchor="ctr" marT="12700" marB="12700" marL="63500" marR="63500">
+                    <a:solidFill>
+                      <a:srgbClr val="FFFFFF"/>
+                    </a:solidFill>
+                  </a:tcPr>
+                </a:tc>
+              </a:tr>
+              <a:tr h="457200">
+                <a:tc>
+                  <a:txBody>
+                    <a:bodyPr wrap="square"/>
+                    <a:lstStyle/>
+                    <a:p>
+                      <a:r>
+                        <a:rPr sz="1500">
+                          <a:solidFill>
+                            <a:srgbClr val="262B2F"/>
+                          </a:solidFill>
+                          <a:latin typeface="Arial"/>
+                        </a:rPr>
+                        <a:t>RF warm speedup</a:t>
+                      </a:r>
+                    </a:p>
+                  </a:txBody>
+                  <a:tcPr anchor="ctr" marT="12700" marB="12700" marL="63500" marR="63500">
+                    <a:solidFill>
+                      <a:srgbClr val="FFFFFF"/>
+                    </a:solidFill>
+                  </a:tcPr>
+                </a:tc>
+                <a:tc>
+                  <a:txBody>
+                    <a:bodyPr wrap="square"/>
+                    <a:lstStyle/>
+                    <a:p>
+                      <a:r>
+                        <a:rPr sz="1500">
+                          <a:solidFill>
+                            <a:srgbClr val="262B2F"/>
+                          </a:solidFill>
+                          <a:latin typeface="Arial"/>
+                        </a:rPr>
+                        <a:t>3–5×</a:t>
+                      </a:r>
+                    </a:p>
+                  </a:txBody>
+                  <a:tcPr anchor="ctr" marT="12700" marB="12700" marL="63500" marR="63500">
+                    <a:solidFill>
+                      <a:srgbClr val="FFFFFF"/>
+                    </a:solidFill>
+                  </a:tcPr>
+                </a:tc>
+                <a:tc>
+                  <a:txBody>
+                    <a:bodyPr wrap="square"/>
+                    <a:lstStyle/>
+                    <a:p>
+                      <a:r>
+                        <a:rPr sz="1500">
+                          <a:solidFill>
+                            <a:srgbClr val="262B2F"/>
+                          </a:solidFill>
+                          <a:latin typeface="Arial"/>
+                        </a:rPr>
+                        <a:t>2.5–2.8×</a:t>
+                      </a:r>
+                    </a:p>
+                  </a:txBody>
+                  <a:tcPr anchor="ctr" marT="12700" marB="12700" marL="63500" marR="63500">
+                    <a:solidFill>
+                      <a:srgbClr val="FFFFFF"/>
+                    </a:solidFill>
+                  </a:tcPr>
+                </a:tc>
+              </a:tr>
+              <a:tr h="457200">
+                <a:tc>
+                  <a:txBody>
+                    <a:bodyPr wrap="square"/>
+                    <a:lstStyle/>
+                    <a:p>
+                      <a:r>
+                        <a:rPr sz="1500">
+                          <a:solidFill>
+                            <a:srgbClr val="262B2F"/>
+                          </a:solidFill>
+                          <a:latin typeface="Arial"/>
+                        </a:rPr>
+                        <a:t>Degrades with N?</a:t>
+                      </a:r>
+                    </a:p>
+                  </a:txBody>
+                  <a:tcPr anchor="ctr" marT="12700" marB="12700" marL="63500" marR="63500">
+                    <a:solidFill>
+                      <a:srgbClr val="FFFFFF"/>
+                    </a:solidFill>
+                  </a:tcPr>
+                </a:tc>
+                <a:tc>
+                  <a:txBody>
+                    <a:bodyPr wrap="square"/>
+                    <a:lstStyle/>
+                    <a:p>
+                      <a:r>
+                        <a:rPr sz="1500">
+                          <a:solidFill>
+                            <a:srgbClr val="262B2F"/>
+                          </a:solidFill>
+                          <a:latin typeface="Arial"/>
+                        </a:rPr>
+                        <a:t>No (fingerprint stable)</a:t>
+                      </a:r>
+                    </a:p>
+                  </a:txBody>
+                  <a:tcPr anchor="ctr" marT="12700" marB="12700" marL="63500" marR="63500">
+                    <a:solidFill>
+                      <a:srgbClr val="FFFFFF"/>
+                    </a:solidFill>
+                  </a:tcPr>
+                </a:tc>
+                <a:tc>
+                  <a:txBody>
+                    <a:bodyPr wrap="square"/>
+                    <a:lstStyle/>
+                    <a:p>
+                      <a:r>
+                        <a:rPr sz="1500">
+                          <a:solidFill>
+                            <a:srgbClr val="262B2F"/>
+                          </a:solidFill>
+                          <a:latin typeface="Arial"/>
+                        </a:rPr>
+                        <a:t>Yes (re-select/fold)</a:t>
+                      </a:r>
+                    </a:p>
+                  </a:txBody>
+                  <a:tcPr anchor="ctr" marT="12700" marB="12700" marL="63500" marR="63500">
+                    <a:solidFill>
+                      <a:srgbClr val="FFFFFF"/>
+                    </a:solidFill>
+                  </a:tcPr>
+                </a:tc>
+              </a:tr>
+              <a:tr h="457200">
+                <a:tc>
+                  <a:txBody>
+                    <a:bodyPr wrap="square"/>
+                    <a:lstStyle/>
+                    <a:p>
+                      <a:r>
+                        <a:rPr sz="1500">
+                          <a:solidFill>
+                            <a:srgbClr val="262B2F"/>
+                          </a:solidFill>
+                          <a:latin typeface="Arial"/>
+                        </a:rPr>
+                        <a:t>Cache key</a:t>
+                      </a:r>
+                    </a:p>
+                  </a:txBody>
+                  <a:tcPr anchor="ctr" marT="12700" marB="12700" marL="63500" marR="63500">
+                    <a:solidFill>
+                      <a:srgbClr val="FFFFFF"/>
+                    </a:solidFill>
+                  </a:tcPr>
+                </a:tc>
+                <a:tc>
+                  <a:txBody>
+                    <a:bodyPr wrap="square"/>
+                    <a:lstStyle/>
+                    <a:p>
+                      <a:r>
+                        <a:rPr sz="1500">
+                          <a:solidFill>
+                            <a:srgbClr val="262B2F"/>
+                          </a:solidFill>
+                          <a:latin typeface="Arial"/>
+                        </a:rPr>
+                        <a:t>One per config</a:t>
+                      </a:r>
+                    </a:p>
+                  </a:txBody>
+                  <a:tcPr anchor="ctr" marT="12700" marB="12700" marL="63500" marR="63500">
+                    <a:solidFill>
+                      <a:srgbClr val="FFFFFF"/>
+                    </a:solidFill>
+                  </a:tcPr>
+                </a:tc>
+                <a:tc>
+                  <a:txBody>
+                    <a:bodyPr wrap="square"/>
+                    <a:lstStyle/>
+                    <a:p>
+                      <a:r>
+                        <a:rPr sz="1500">
+                          <a:solidFill>
+                            <a:srgbClr val="262B2F"/>
+                          </a:solidFill>
+                          <a:latin typeface="Arial"/>
+                        </a:rPr>
+                        <a:t>One per fold</a:t>
+                      </a:r>
+                    </a:p>
+                  </a:txBody>
+                  <a:tcPr anchor="ctr" marT="12700" marB="12700" marL="63500" marR="63500">
+                    <a:solidFill>
+                      <a:srgbClr val="FFFFFF"/>
+                    </a:solidFill>
+                  </a:tcPr>
+                </a:tc>
+              </a:tr>
+            </a:tbl>
+          </a:graphicData>
+        </a:graphic>
+      </p:graphicFrame>
+      <p:sp>
+        <p:nvSpPr>
+          <p:cNvPr id="4" name="TextBox 3"/>
+          <p:cNvSpPr txBox="1"/>
+          <p:nvPr/>
+        </p:nvSpPr>
+        <p:spPr>
+          <a:xfrm>
+            <a:off x="822960" y="5623560"/>
+            <a:ext cx="10515600" cy="365760"/>
+          </a:xfrm>
+          <a:prstGeom prst="rect">
+            <a:avLst/>
+          </a:prstGeom>
+          <a:noFill/>
+        </p:spPr>
+        <p:txBody>
+          <a:bodyPr wrap="square">
+            <a:spAutoFit/>
+          </a:bodyPr>
+          <a:lstStyle/>
+          <a:p>
+            <a:pPr algn="ctr"/>
+            <a:r>
+              <a:rPr sz="1200" i="1">
+                <a:solidFill>
+                  <a:srgbClr val="768692"/>
+                </a:solidFill>
+              </a:rPr>
+              <a:t>Global selection retains the cache speedup; measured accuracy impact ≤1.1% with no consistent direction.</a:t>
+            </a:r>
+          </a:p>
+        </p:txBody>
+      </p:sp>
+    </p:spTree>
   </p:cSld>
   <p:clrMapOvr>
     <a:masterClrMapping/>

</xml_diff>

<commit_message>
Apply mock-defense feedback: RQs, viability rationale, fold-identity clarification
- Slide 3: add LOSO-as-gold-standard bullet; replace thin Framing section with
  four explicit Research Questions (RQ1–RQ4) so they appear before SOTA
- Slide 5: add 'Why not generic caching?' header + bullet explaining silent
  wrong-subject hit; extend speaker note with the floor-question answer
- Slide 8: add 'Threshold from empirical gap — not arbitrary' bullet; extend
  note with the near-decade cluster gap explanation
- Slide 9: replace vague 'Bonus' bullet with concrete outlier-inspection
  examples; replace 'RQ1–RQ4: answered' with four explicit tick-off answers
  matching the numbers from results slides

https://claude.ai/code/session_01P9syRDuxUEthFVf8zcHciC
</commit_message>
<xml_diff>
--- a/thesis/presentation/Thesis_Presentation_Gorzel.pptx
+++ b/thesis/presentation/Thesis_Presentation_Gorzel.pptx
@@ -1379,7 +1379,7 @@
           <a:lstStyle/>
           <a:p>
             <a:r>
-              <a:t>This began as a sleep-staging project. The standard protocol is Leave-One-Subject-Out: train on 127 people, test on the one held out, repeat for all 128 — so per model, 128 retrains. Run 18 model configurations and you're at ~21 hours per sweep, mostly recomputing byte-for-byte identical models. The problem was never accuracy; it was that changing one parameter threw all of it away. And to be clear: sleep data is just the vehicle. The contribution is the caching framework — LOSO is the hard, general case I use to prove it. (~1:40)</a:t>
+              <a:t>This began as a sleep-staging project. LOSO is not just one option — in clinical and medical ML it is the preferred protocol because it enforces true subject independence. With 128 subjects and 18 model configurations you're at ~21 hours per sweep, mostly recomputing byte-for-byte identical models. Changing one parameter throws all of it away. Sleep EEG is just the vehicle; the contribution is the caching framework. These four research questions guide the rest of the talk — I'll answer each one explicitly in the conclusion. (~2:00)</a:t>
             </a:r>
           </a:p>
         </p:txBody>
@@ -1519,7 +1519,7 @@
           <a:lstStyle/>
           <a:p>
             <a:r>
-              <a:t>The mechanism is one idea: give every computation an identity. I take the full configuration — seed, code version, hyperparameters, feature set — serialize it to canonical JSON, and hash it with SHA-256. Same inputs always give the same key; change one thing and the key changes, forcing a recompute. The decisive part, and the reason generic tools can't do this, is adding the held-out subject ID into the hash. That makes fold isolation structural, not a convention: a model trained with subject A out cannot be retrieved when subject B is the test subject. (Slide 2 was the problem; this is the one idea that fixes it.) (~1:30)</a:t>
+              <a:t>The mechanism is one idea: give every computation an identity. I take the full configuration — seed, code version, hyperparameters, feature set — serialize it to canonical JSON, and hash it with SHA-256. Same inputs always give the same key; change one thing and the key changes, forcing a recompute. The decisive part, and the reason generic tools cannot do this, is adding the held-out subject ID into the hash. That makes fold isolation structural, not a convention: a model trained with subject A out cannot be retrieved when subject B is the test subject. Any caching library can store a file by key — what makes this fingerprint-based is that the key is derived from ALL inputs including the held-out subject ID. Without that, a cache hit could silently return a model trained on the wrong 127 people with no error raised. (~1:30)</a:t>
             </a:r>
           </a:p>
         </p:txBody>
@@ -1729,7 +1729,7 @@
           <a:lstStyle/>
           <a:p>
             <a:r>
-              <a:t>Caching isn't free for every model, so I built a metric — eta, the same symbol physics uses for efficiency — seconds of compute saved per megabyte stored. I tested 15 models. Everything above this diagonal recovers more compute than it spends on storage I/O: 11 pass, 4 fail. The failures cluster bottom-right — Random Forest, Extra Trees, kNN — big files, little saved. And the scaling result is the general takeaway: SVM went from 9x at ten subjects to 201x at 128. Caching gets MORE valuable as the study grows, not less. (~1:20)</a:t>
+              <a:t>Caching isn't free for every model, so I built a metric — eta, the same symbol physics uses for efficiency — seconds of compute saved per megabyte stored. I tested 15 models. Everything above this diagonal recovers more compute than it spends on storage I/O: 11 pass, 4 fail. The failures cluster bottom-right — Random Forest, Extra Trees, kNN — big files, little saved. The threshold wasn't picked arbitrarily: after measuring all 15 models, the viable cluster landed between 4 and 2,500 s/MB; the not-viable cluster between 0.19 and 0.4 s/MB — a near-decade gap on a log scale. The threshold just needs to sit inside that gap; the exact value doesn't change any verdict. And the scaling result is the general takeaway: SVM went from 9x at ten subjects to 201x at 128. Caching gets MORE valuable as the study grows, not less. (~1:20)</a:t>
             </a:r>
           </a:p>
         </p:txBody>
@@ -21003,7 +21003,7 @@
               </a:spcAft>
             </a:pPr>
             <a:r>
-              <a:rPr sz="2000" b="1">
+              <a:rPr sz="1800" b="1">
                 <a:solidFill>
                   <a:srgbClr val="FF9E1B"/>
                 </a:solidFill>
@@ -21019,8 +21019,8 @@
               </a:spcAft>
             </a:pPr>
             <a:r>
-              <a:rPr sz="1800" b="0"/>
-              <a:t>EEG sleep staging — 128 subjects</a:t>
+              <a:rPr sz="1600" b="0"/>
+              <a:t>EEG sleep staging — 128 subjects, BOAS dataset</a:t>
             </a:r>
           </a:p>
           <a:p>
@@ -21030,8 +21030,8 @@
               </a:spcAft>
             </a:pPr>
             <a:r>
-              <a:rPr sz="1800" b="0"/>
-              <a:t>LOSO: one model per held-out subject</a:t>
+              <a:rPr sz="1600" b="0"/>
+              <a:t>LOSO: gold standard for subject-independent medical ML</a:t>
             </a:r>
           </a:p>
           <a:p>
@@ -21044,7 +21044,7 @@
               </a:spcAft>
             </a:pPr>
             <a:r>
-              <a:rPr sz="2000" b="1">
+              <a:rPr sz="1800" b="1">
                 <a:solidFill>
                   <a:srgbClr val="FF9E1B"/>
                 </a:solidFill>
@@ -21059,8 +21059,8 @@
               </a:spcAft>
             </a:pPr>
             <a:r>
-              <a:rPr sz="1800" b="0"/>
-              <a:t>Per model: 128 subjects → 128 retrains</a:t>
+              <a:rPr sz="1600" b="0"/>
+              <a:t>128 subjects × 18 configs ≈ 21 hours per sweep</a:t>
             </a:r>
           </a:p>
           <a:p>
@@ -21070,8 +21070,26 @@
               </a:spcAft>
             </a:pPr>
             <a:r>
-              <a:rPr sz="1800" b="0"/>
-              <a:t>18 model configs ≈ 21 hours</a:t>
+              <a:rPr sz="1600" b="0"/>
+              <a:t>Change one parameter → recompute all folds</a:t>
+            </a:r>
+          </a:p>
+          <a:p>
+            <a:pPr>
+              <a:spcBef>
+                <a:spcPts val="800"/>
+              </a:spcBef>
+              <a:spcAft>
+                <a:spcPts val="400"/>
+              </a:spcAft>
+            </a:pPr>
+            <a:r>
+              <a:rPr sz="1800" b="1">
+                <a:solidFill>
+                  <a:srgbClr val="FF9E1B"/>
+                </a:solidFill>
+              </a:rPr>
+              <a:t>Research Questions</a:t>
             </a:r>
           </a:p>
           <a:p>
@@ -21081,26 +21099,19 @@
               </a:spcAft>
             </a:pPr>
             <a:r>
-              <a:rPr sz="1800" b="0"/>
-              <a:t>Change one parameter → recompute all</a:t>
-            </a:r>
-          </a:p>
-          <a:p>
-            <a:pPr>
-              <a:spcBef>
-                <a:spcPts val="800"/>
-              </a:spcBef>
+              <a:rPr sz="1600" b="0"/>
+              <a:t>RQ1: What speedup and hit rates does caching achieve?</a:t>
+            </a:r>
+          </a:p>
+          <a:p>
+            <a:pPr lvl="1">
               <a:spcAft>
                 <a:spcPts val="400"/>
               </a:spcAft>
             </a:pPr>
             <a:r>
-              <a:rPr sz="2000" b="1">
-                <a:solidFill>
-                  <a:srgbClr val="FF9E1B"/>
-                </a:solidFill>
-              </a:rPr>
-              <a:t>Framing</a:t>
+              <a:rPr sz="1600" b="0"/>
+              <a:t>RQ2: Are cached results bitwise-identical?</a:t>
             </a:r>
           </a:p>
           <a:p>
@@ -21110,8 +21121,19 @@
               </a:spcAft>
             </a:pPr>
             <a:r>
-              <a:rPr sz="1800" b="0"/>
-              <a:t>Sleep EEG = vehicle, not the goal</a:t>
+              <a:rPr sz="1600" b="0"/>
+              <a:t>RQ3: Does benefit scale with subject count N?</a:t>
+            </a:r>
+          </a:p>
+          <a:p>
+            <a:pPr lvl="1">
+              <a:spcAft>
+                <a:spcPts val="400"/>
+              </a:spcAft>
+            </a:pPr>
+            <a:r>
+              <a:rPr sz="1600" b="0"/>
+              <a:t>RQ4: When is caching storage-efficient (η)?</a:t>
             </a:r>
           </a:p>
         </p:txBody>
@@ -21826,7 +21848,7 @@
               <a:buChar char="•"/>
             </a:pPr>
             <a:r>
-              <a:rPr sz="2000" b="1">
+              <a:rPr sz="1800" b="1">
                 <a:solidFill>
                   <a:srgbClr val="FF9E1B"/>
                 </a:solidFill>
@@ -21842,7 +21864,7 @@
               </a:spcAft>
             </a:pPr>
             <a:r>
-              <a:rPr sz="1800" b="0"/>
+              <a:rPr sz="1600" b="0"/>
               <a:t>Fingerprint = SHA-256(all inputs)</a:t>
             </a:r>
           </a:p>
@@ -21853,7 +21875,7 @@
               </a:spcAft>
             </a:pPr>
             <a:r>
-              <a:rPr sz="1800" b="0"/>
+              <a:rPr sz="1600" b="0"/>
               <a:t>Inputs: seed, code, params, features</a:t>
             </a:r>
           </a:p>
@@ -21864,7 +21886,7 @@
               </a:spcAft>
             </a:pPr>
             <a:r>
-              <a:rPr sz="1800" b="0"/>
+              <a:rPr sz="1600" b="0"/>
               <a:t>Plus the held-out subject ID</a:t>
             </a:r>
           </a:p>
@@ -21878,7 +21900,7 @@
               </a:spcAft>
             </a:pPr>
             <a:r>
-              <a:rPr sz="2000" b="1">
+              <a:rPr sz="1800" b="1">
                 <a:solidFill>
                   <a:srgbClr val="FF9E1B"/>
                 </a:solidFill>
@@ -21893,7 +21915,7 @@
               </a:spcAft>
             </a:pPr>
             <a:r>
-              <a:rPr sz="1800" b="0"/>
+              <a:rPr sz="1600" b="0"/>
               <a:t>Same config → same key → reuse</a:t>
             </a:r>
           </a:p>
@@ -21904,8 +21926,37 @@
               </a:spcAft>
             </a:pPr>
             <a:r>
-              <a:rPr sz="1800" b="0"/>
+              <a:rPr sz="1600" b="0"/>
               <a:t>Change anything → new key → recompute</a:t>
+            </a:r>
+          </a:p>
+          <a:p>
+            <a:pPr>
+              <a:spcBef>
+                <a:spcPts val="800"/>
+              </a:spcBef>
+              <a:spcAft>
+                <a:spcPts val="400"/>
+              </a:spcAft>
+            </a:pPr>
+            <a:r>
+              <a:rPr sz="1800" b="1">
+                <a:solidFill>
+                  <a:srgbClr val="FF9E1B"/>
+                </a:solidFill>
+              </a:rPr>
+              <a:t>Why not generic caching?</a:t>
+            </a:r>
+          </a:p>
+          <a:p>
+            <a:pPr lvl="1">
+              <a:spcAft>
+                <a:spcPts val="400"/>
+              </a:spcAft>
+            </a:pPr>
+            <a:r>
+              <a:rPr sz="1600" b="0"/>
+              <a:t>No fold identity → wrong-subject hit is silent</a:t>
             </a:r>
           </a:p>
         </p:txBody>
@@ -22836,6 +22887,17 @@
             </a:pPr>
             <a:r>
               <a:rPr sz="1600" b="0"/>
+              <a:t>Threshold from empirical gap — not arbitrary</a:t>
+            </a:r>
+          </a:p>
+          <a:p>
+            <a:pPr lvl="1">
+              <a:spcAft>
+                <a:spcPts val="400"/>
+              </a:spcAft>
+            </a:pPr>
+            <a:r>
+              <a:rPr sz="1600" b="0"/>
               <a:t>Above the line → worth caching</a:t>
             </a:r>
           </a:p>
@@ -23128,7 +23190,7 @@
               <a:buChar char="•"/>
             </a:pPr>
             <a:r>
-              <a:rPr sz="2000" b="1">
+              <a:rPr sz="1700" b="1">
                 <a:solidFill>
                   <a:srgbClr val="FF9E1B"/>
                 </a:solidFill>
@@ -23144,7 +23206,7 @@
               </a:spcAft>
             </a:pPr>
             <a:r>
-              <a:rPr sz="1800" b="0"/>
+              <a:rPr sz="1500" b="0"/>
               <a:t>Fold-aware fingerprint → no contamination</a:t>
             </a:r>
           </a:p>
@@ -23155,7 +23217,7 @@
               </a:spcAft>
             </a:pPr>
             <a:r>
-              <a:rPr sz="1800" b="0"/>
+              <a:rPr sz="1500" b="0"/>
               <a:t>Order-of-magnitude speedup, reproducible</a:t>
             </a:r>
           </a:p>
@@ -23166,8 +23228,19 @@
               </a:spcAft>
             </a:pPr>
             <a:r>
-              <a:rPr sz="1800" b="0"/>
-              <a:t>Bonus: every fold's model preserved</a:t>
+              <a:rPr sz="1500" b="0"/>
+              <a:t>Every fold's model preserved → inspect post-hoc</a:t>
+            </a:r>
+          </a:p>
+          <a:p>
+            <a:pPr lvl="1">
+              <a:spcAft>
+                <a:spcPts val="400"/>
+              </a:spcAft>
+            </a:pPr>
+            <a:r>
+              <a:rPr sz="1500" b="0"/>
+              <a:t>Outlier flagged → pull model, inspect feature weights</a:t>
             </a:r>
           </a:p>
           <a:p>
@@ -23180,12 +23253,12 @@
               </a:spcAft>
             </a:pPr>
             <a:r>
-              <a:rPr sz="2000" b="1">
+              <a:rPr sz="1700" b="1">
                 <a:solidFill>
                   <a:srgbClr val="FF9E1B"/>
                 </a:solidFill>
               </a:rPr>
-              <a:t>Takeaways</a:t>
+              <a:t>Research Questions — Answered</a:t>
             </a:r>
           </a:p>
           <a:p>
@@ -23195,8 +23268,8 @@
               </a:spcAft>
             </a:pPr>
             <a:r>
-              <a:rPr sz="1800" b="0"/>
-              <a:t>Caching scales with study size</a:t>
+              <a:rPr sz="1500" b="0"/>
+              <a:t>RQ1 ✓  median 54×, 100% hit rate, 2,304/2,304</a:t>
             </a:r>
           </a:p>
           <a:p>
@@ -23206,8 +23279,8 @@
               </a:spcAft>
             </a:pPr>
             <a:r>
-              <a:rPr sz="1800" b="0"/>
-              <a:t>Method transfers — the numbers don't</a:t>
+              <a:rPr sz="1500" b="0"/>
+              <a:t>RQ2 ✓  100% bitwise-identical, zero collisions</a:t>
             </a:r>
           </a:p>
           <a:p>
@@ -23217,8 +23290,19 @@
               </a:spcAft>
             </a:pPr>
             <a:r>
-              <a:rPr sz="1800" b="0"/>
-              <a:t>RQ1–RQ4: answered</a:t>
+              <a:rPr sz="1500" b="0"/>
+              <a:t>RQ3 ✓  speedup grows: SVM 9× → 201×</a:t>
+            </a:r>
+          </a:p>
+          <a:p>
+            <a:pPr lvl="1">
+              <a:spcAft>
+                <a:spcPts val="400"/>
+              </a:spcAft>
+            </a:pPr>
+            <a:r>
+              <a:rPr sz="1500" b="0"/>
+              <a:t>RQ4 ✓  11/15 viable; η separates clusters by ~3 orders</a:t>
             </a:r>
           </a:p>
         </p:txBody>

</xml_diff>

<commit_message>
Add cover hook bullets + headline-T Motivation layout
- Cover: two spoken-hook bullets (post-hoc inspection; ML specialist +
  clinician outlier review) in the title block's spacer paragraphs, with a
  ~0:30 hook in the notes. Bookends with the conclusion payoff.
- Motivation: redesign as headline band + two columns. Full-width number band
  (18 × 128 = 2,304 trainings → ~21 h, count in orange) over an orange divider;
  'Why it's hard' left, RQ1–RQ4 right. Prose 'Why Cache' line dropped (spoken);
  typos fixed; notes expanded to ~2:00 with full RQ wording.
- Outline left unchanged; its 'Research Questions' label is now accurate.

https://claude.ai/code/session_01P9syRDuxUEthFVf8zcHciC
</commit_message>
<xml_diff>
--- a/thesis/presentation/Thesis_Presentation_Gorzel.pptx
+++ b/thesis/presentation/Thesis_Presentation_Gorzel.pptx
@@ -802,8 +802,9 @@
           <a:bodyPr/>
           <a:lstStyle/>
           <a:p>
-            <a:pPr lvl="0"/>
-            <a:endParaRPr lang="de-DE" dirty="0"/>
+            <a:r>
+              <a:t>Open with the hook (~0:30). Two concrete payoffs of this work, in plain terms. First: because every fold's model is cached and preserved, you can inspect any single subject's model after the fact — open the box, not just read the score. Second: that enables a workflow where a clinician flags an unusual subject and an ML specialist pulls that exact model to check its feature weights — at zero extra compute, because it is already cached. Keep it brief here; I deliver the proof at the end. Then move to the agenda.</a:t>
+            </a:r>
           </a:p>
         </p:txBody>
       </p:sp>
@@ -1379,7 +1380,7 @@
           <a:lstStyle/>
           <a:p>
             <a:r>
-              <a:t>This began as a sleep-staging project. LOSO is not just one option — in clinical and medical ML it is the preferred protocol because it enforces true subject independence. With 128 subjects and 18 model configurations you're at ~21 hours per sweep, mostly recomputing byte-for-byte identical models. Changing one parameter throws all of it away. Sleep EEG is just the vehicle; the contribution is the caching framework. These four research questions guide the rest of the talk — I'll answer each one explicitly in the conclusion. (~2:00)</a:t>
+              <a:t>Lead with the number on the band: 18 model configurations across 128 subjects is 2,304 trainings, about 21 hours per sweep — and almost all of it is recomputing byte-for-byte identical models. Why so many folds? Because LOSO is not just one option — in clinical and medical ML it is the preferred protocol, since it enforces true subject independence: one model per held-out subject. The pain is that changing a single parameter throws the whole sweep away. That motivates four research questions — read each in full: RQ1, what speedup and hit rates does caching achieve; RQ2, are the cached results bitwise-identical to retraining; RQ3, does the benefit scale as the subject count N grows; RQ4, when is caching storage-efficient, measured by eta. I answer all four explicitly in the conclusion. (~2:00)</a:t>
             </a:r>
           </a:p>
         </p:txBody>
@@ -16966,10 +16967,26 @@
           </a:p>
           <a:p>
             <a:pPr algn="ctr"/>
+            <a:r>
+              <a:rPr sz="1600" b="1">
+                <a:solidFill>
+                  <a:srgbClr val="FF9E1B"/>
+                </a:solidFill>
+              </a:rPr>
+              <a:t>▸  Post-hoc per-fold model inspection</a:t>
+            </a:r>
             <a:endParaRPr lang="de-DE" dirty="0"/>
           </a:p>
           <a:p>
             <a:pPr algn="ctr"/>
+            <a:r>
+              <a:rPr sz="1600" b="1">
+                <a:solidFill>
+                  <a:srgbClr val="FF9E1B"/>
+                </a:solidFill>
+              </a:rPr>
+              <a:t>▸  ML specialist + clinician: outlier review at zero extra cost</a:t>
+            </a:r>
             <a:endParaRPr lang="de-DE" dirty="0"/>
           </a:p>
           <a:p>
@@ -20986,8 +21003,8 @@
         </p:nvSpPr>
         <p:spPr>
           <a:xfrm>
-            <a:off x="686386" y="1528455"/>
-            <a:ext cx="10873283" cy="4583405"/>
+            <a:off x="685800" y="2560320"/>
+            <a:ext cx="5120640" cy="3108960"/>
           </a:xfrm>
         </p:spPr>
         <p:txBody>
@@ -21008,7 +21025,7 @@
                   <a:srgbClr val="FF9E1B"/>
                 </a:solidFill>
               </a:rPr>
-              <a:t>Context</a:t>
+              <a:t>Why it's hard</a:t>
             </a:r>
             <a:endParaRPr lang="de-DE" b="1" dirty="0"/>
           </a:p>
@@ -21020,7 +21037,7 @@
             </a:pPr>
             <a:r>
               <a:rPr sz="1600" b="0"/>
-              <a:t>EEG sleep staging — 128 subjects, BOAS dataset</a:t>
+              <a:t>Sleep EEG · BOAS dataset · 128 subjects</a:t>
             </a:r>
           </a:p>
           <a:p>
@@ -21031,36 +21048,18 @@
             </a:pPr>
             <a:r>
               <a:rPr sz="1600" b="0"/>
-              <a:t>LOSO: gold standard for subject-independent medical ML</a:t>
-            </a:r>
-          </a:p>
-          <a:p>
-            <a:pPr>
-              <a:spcBef>
-                <a:spcPts val="800"/>
-              </a:spcBef>
+              <a:t>LOSO = gold standard in medical ML</a:t>
+            </a:r>
+          </a:p>
+          <a:p>
+            <a:pPr lvl="1">
               <a:spcAft>
                 <a:spcPts val="400"/>
               </a:spcAft>
             </a:pPr>
             <a:r>
-              <a:rPr sz="1800" b="1">
-                <a:solidFill>
-                  <a:srgbClr val="FF9E1B"/>
-                </a:solidFill>
-              </a:rPr>
-              <a:t>The Challenge</a:t>
-            </a:r>
-          </a:p>
-          <a:p>
-            <a:pPr lvl="1">
-              <a:spcAft>
-                <a:spcPts val="400"/>
-              </a:spcAft>
-            </a:pPr>
-            <a:r>
               <a:rPr sz="1600" b="0"/>
-              <a:t>128 subjects × 18 configs ≈ 21 hours per sweep</a:t>
+              <a:t>Subject-independent → 1 model per held-out subject</a:t>
             </a:r>
           </a:p>
           <a:p>
@@ -21072,68 +21071,6 @@
             <a:r>
               <a:rPr sz="1600" b="0"/>
               <a:t>Change one parameter → recompute all folds</a:t>
-            </a:r>
-          </a:p>
-          <a:p>
-            <a:pPr>
-              <a:spcBef>
-                <a:spcPts val="800"/>
-              </a:spcBef>
-              <a:spcAft>
-                <a:spcPts val="400"/>
-              </a:spcAft>
-            </a:pPr>
-            <a:r>
-              <a:rPr sz="1800" b="1">
-                <a:solidFill>
-                  <a:srgbClr val="FF9E1B"/>
-                </a:solidFill>
-              </a:rPr>
-              <a:t>Research Questions</a:t>
-            </a:r>
-          </a:p>
-          <a:p>
-            <a:pPr lvl="1">
-              <a:spcAft>
-                <a:spcPts val="400"/>
-              </a:spcAft>
-            </a:pPr>
-            <a:r>
-              <a:rPr sz="1600" b="0"/>
-              <a:t>RQ1: What speedup and hit rates does caching achieve?</a:t>
-            </a:r>
-          </a:p>
-          <a:p>
-            <a:pPr lvl="1">
-              <a:spcAft>
-                <a:spcPts val="400"/>
-              </a:spcAft>
-            </a:pPr>
-            <a:r>
-              <a:rPr sz="1600" b="0"/>
-              <a:t>RQ2: Are cached results bitwise-identical?</a:t>
-            </a:r>
-          </a:p>
-          <a:p>
-            <a:pPr lvl="1">
-              <a:spcAft>
-                <a:spcPts val="400"/>
-              </a:spcAft>
-            </a:pPr>
-            <a:r>
-              <a:rPr sz="1600" b="0"/>
-              <a:t>RQ3: Does benefit scale with subject count N?</a:t>
-            </a:r>
-          </a:p>
-          <a:p>
-            <a:pPr lvl="1">
-              <a:spcAft>
-                <a:spcPts val="400"/>
-              </a:spcAft>
-            </a:pPr>
-            <a:r>
-              <a:rPr sz="1600" b="0"/>
-              <a:t>RQ4: When is caching storage-efficient (η)?</a:t>
             </a:r>
           </a:p>
         </p:txBody>
@@ -21222,6 +21159,176 @@
               <a:t>6/9/2026</a:t>
             </a:fld>
             <a:endParaRPr lang="de-DE" dirty="0"/>
+          </a:p>
+        </p:txBody>
+      </p:sp>
+      <p:sp>
+        <p:nvSpPr>
+          <p:cNvPr id="8" name="TextBox 7"/>
+          <p:cNvSpPr txBox="1"/>
+          <p:nvPr/>
+        </p:nvSpPr>
+        <p:spPr>
+          <a:xfrm>
+            <a:off x="685800" y="1463040"/>
+            <a:ext cx="10835640" cy="777240"/>
+          </a:xfrm>
+          <a:prstGeom prst="rect">
+            <a:avLst/>
+          </a:prstGeom>
+          <a:noFill/>
+        </p:spPr>
+        <p:txBody>
+          <a:bodyPr wrap="square" anchor="ctr">
+            <a:spAutoFit/>
+          </a:bodyPr>
+          <a:lstStyle/>
+          <a:p>
+            <a:pPr algn="ctr"/>
+            <a:r>
+              <a:rPr sz="2400" b="1">
+                <a:solidFill>
+                  <a:srgbClr val="262B2F"/>
+                </a:solidFill>
+              </a:rPr>
+              <a:t>18 models × 128 subjects = </a:t>
+            </a:r>
+            <a:r>
+              <a:rPr sz="2400" b="1">
+                <a:solidFill>
+                  <a:srgbClr val="FF9E1B"/>
+                </a:solidFill>
+              </a:rPr>
+              <a:t>2,304 trainings → ~21 h / sweep</a:t>
+            </a:r>
+          </a:p>
+        </p:txBody>
+      </p:sp>
+      <p:sp>
+        <p:nvSpPr>
+          <p:cNvPr id="9" name="Rectangle 8"/>
+          <p:cNvSpPr/>
+          <p:nvPr/>
+        </p:nvSpPr>
+        <p:spPr>
+          <a:xfrm>
+            <a:off x="822960" y="2331720"/>
+            <a:ext cx="10561320" cy="25400"/>
+          </a:xfrm>
+          <a:prstGeom prst="rect">
+            <a:avLst/>
+          </a:prstGeom>
+          <a:solidFill>
+            <a:srgbClr val="FF9E1B"/>
+          </a:solidFill>
+          <a:ln>
+            <a:noFill/>
+          </a:ln>
+        </p:spPr>
+        <p:style>
+          <a:lnRef idx="1">
+            <a:schemeClr val="accent1"/>
+          </a:lnRef>
+          <a:fillRef idx="3">
+            <a:schemeClr val="accent1"/>
+          </a:fillRef>
+          <a:effectRef idx="2">
+            <a:schemeClr val="accent1"/>
+          </a:effectRef>
+          <a:fontRef idx="minor">
+            <a:schemeClr val="lt1"/>
+          </a:fontRef>
+        </p:style>
+        <p:txBody>
+          <a:bodyPr rtlCol="0" anchor="ctr"/>
+          <a:lstStyle/>
+          <a:p>
+            <a:pPr algn="ctr"/>
+          </a:p>
+        </p:txBody>
+      </p:sp>
+      <p:sp>
+        <p:nvSpPr>
+          <p:cNvPr id="10" name="TextBox 9"/>
+          <p:cNvSpPr txBox="1"/>
+          <p:nvPr/>
+        </p:nvSpPr>
+        <p:spPr>
+          <a:xfrm>
+            <a:off x="6355080" y="2560320"/>
+            <a:ext cx="5212080" cy="3108960"/>
+          </a:xfrm>
+          <a:prstGeom prst="rect">
+            <a:avLst/>
+          </a:prstGeom>
+          <a:noFill/>
+        </p:spPr>
+        <p:txBody>
+          <a:bodyPr wrap="square">
+            <a:spAutoFit/>
+          </a:bodyPr>
+          <a:lstStyle/>
+          <a:p>
+            <a:pPr>
+              <a:spcBef>
+                <a:spcPts val="800"/>
+              </a:spcBef>
+              <a:spcAft>
+                <a:spcPts val="400"/>
+              </a:spcAft>
+            </a:pPr>
+            <a:r>
+              <a:rPr sz="1800" b="1">
+                <a:solidFill>
+                  <a:srgbClr val="FF9E1B"/>
+                </a:solidFill>
+              </a:rPr>
+              <a:t>Research Questions</a:t>
+            </a:r>
+          </a:p>
+          <a:p>
+            <a:pPr lvl="1">
+              <a:spcAft>
+                <a:spcPts val="400"/>
+              </a:spcAft>
+            </a:pPr>
+            <a:r>
+              <a:rPr sz="1600" b="0"/>
+              <a:t>RQ1 — Speedup &amp; hit rate?</a:t>
+            </a:r>
+          </a:p>
+          <a:p>
+            <a:pPr lvl="1">
+              <a:spcAft>
+                <a:spcPts val="400"/>
+              </a:spcAft>
+            </a:pPr>
+            <a:r>
+              <a:rPr sz="1600" b="0"/>
+              <a:t>RQ2 — Bitwise-identical?</a:t>
+            </a:r>
+          </a:p>
+          <a:p>
+            <a:pPr lvl="1">
+              <a:spcAft>
+                <a:spcPts val="400"/>
+              </a:spcAft>
+            </a:pPr>
+            <a:r>
+              <a:rPr sz="1600" b="0"/>
+              <a:t>RQ3 — Scaling with N?</a:t>
+            </a:r>
+          </a:p>
+          <a:p>
+            <a:pPr lvl="1">
+              <a:spcAft>
+                <a:spcPts val="400"/>
+              </a:spcAft>
+            </a:pPr>
+            <a:r>
+              <a:rPr sz="1600" b="0"/>
+              <a:t>RQ4 — Storage-efficient (η)?</a:t>
+            </a:r>
           </a:p>
         </p:txBody>
       </p:sp>

</xml_diff>